<commit_message>
Final keynote polish for Dutch deck
</commit_message>
<xml_diff>
--- a/release/Moltbook.pptx
+++ b/release/Moltbook.pptx
@@ -603,7 +603,11 @@
             <a:r>
               <a:rPr lang="en-US" dirty="0"/>
               <a:t>Laat deze slide rustig landen. Niet te snel naar de vragen springen.
-Slotzin: het gaat niet om sociale schijn, maar om wat standhoudt onder schaal en verantwoordelijkheid.</a:t>
+Slotzin: het gaat niet om sociale schijn, maar om wat standhoudt onder schaal en verantwoordelijkheid.
+Gespreksvragen
+- Welke delen van uw agentstack worden vandaag nog telkens gereconstrueerd?
+- Waar breekt governance eerst?
+- Welke cijfers zijn gemeten, en welke zijn nog scenario-aannames?</a:t>
             </a:r>
             <a:endParaRPr lang="en-US" dirty="0"/>
           </a:p>
@@ -2553,7 +2557,7 @@
         </p:nvSpPr>
         <p:spPr>
           <a:xfrm>
-            <a:off x="713232" y="1481328"/>
+            <a:off x="713232" y="1426464"/>
             <a:ext cx="10058400" cy="493776"/>
           </a:xfrm>
           <a:prstGeom prst="rect">
@@ -2572,7 +2576,7 @@
               <a:buNone/>
             </a:pPr>
             <a:r>
-              <a:rPr lang="en-US" sz="2600" b="1" dirty="0">
+              <a:rPr lang="en-US" sz="2800" b="1" dirty="0">
                 <a:solidFill>
                   <a:srgbClr val="FFFFFF"/>
                 </a:solidFill>
@@ -2582,7 +2586,7 @@
               </a:rPr>
               <a:t>De juiste vraag is niet of de demo sociaal oogt.</a:t>
             </a:r>
-            <a:endParaRPr lang="en-US" sz="2600" dirty="0"/>
+            <a:endParaRPr lang="en-US" sz="2800" dirty="0"/>
           </a:p>
         </p:txBody>
       </p:sp>
@@ -2594,8 +2598,8 @@
         </p:nvSpPr>
         <p:spPr>
           <a:xfrm>
-            <a:off x="1042416" y="2267712"/>
-            <a:ext cx="9418320" cy="896112"/>
+            <a:off x="877824" y="2212848"/>
+            <a:ext cx="10149840" cy="914400"/>
           </a:xfrm>
           <a:prstGeom prst="rect">
             <a:avLst/>
@@ -2613,7 +2617,7 @@
               <a:buNone/>
             </a:pPr>
             <a:r>
-              <a:rPr lang="en-US" sz="2400" b="1" dirty="0">
+              <a:rPr lang="en-US" sz="2700" b="1" dirty="0">
                 <a:solidFill>
                   <a:srgbClr val="F2AD18"/>
                 </a:solidFill>
@@ -2621,9 +2625,9 @@
                 <a:ea typeface="Aptos Display" pitchFamily="34" charset="-122"/>
                 <a:cs typeface="Aptos Display" pitchFamily="34" charset="-120"/>
               </a:rPr>
-              <a:t>De juiste vraag is of identiteit, geheugen, governance en kost standhouden zodra je schaal en verantwoordelijkheid serieus neemt.</a:t>
-            </a:r>
-            <a:endParaRPr lang="en-US" sz="2400" dirty="0"/>
+              <a:t>De juiste vraag is of identiteit, geheugen, governance en kost standhouden zodra schaal en verantwoordelijkheid echt meetellen.</a:t>
+            </a:r>
+            <a:endParaRPr lang="en-US" sz="2700" dirty="0"/>
           </a:p>
         </p:txBody>
       </p:sp>
@@ -2635,12 +2639,12 @@
         </p:nvSpPr>
         <p:spPr>
           <a:xfrm>
-            <a:off x="969264" y="3822192"/>
-            <a:ext cx="10241280" cy="1005840"/>
+            <a:off x="969264" y="3913632"/>
+            <a:ext cx="10241280" cy="1078992"/>
           </a:xfrm>
           <a:prstGeom prst="roundRect">
             <a:avLst>
-              <a:gd name="adj" fmla="val 5455"/>
+              <a:gd name="adj" fmla="val 5085"/>
             </a:avLst>
           </a:prstGeom>
           <a:solidFill>
@@ -2662,7 +2666,7 @@
         </p:nvSpPr>
         <p:spPr>
           <a:xfrm>
-            <a:off x="1261872" y="4114800"/>
+            <a:off x="1261872" y="4187952"/>
             <a:ext cx="1280160" cy="182880"/>
           </a:xfrm>
           <a:prstGeom prst="rect">
@@ -2703,8 +2707,8 @@
         </p:nvSpPr>
         <p:spPr>
           <a:xfrm>
-            <a:off x="1261872" y="4407408"/>
-            <a:ext cx="9326880" cy="310896"/>
+            <a:off x="1261872" y="4498848"/>
+            <a:ext cx="9326880" cy="384048"/>
           </a:xfrm>
           <a:prstGeom prst="rect">
             <a:avLst/>
@@ -2722,75 +2726,48 @@
               <a:buNone/>
             </a:pPr>
             <a:r>
-              <a:rPr lang="en-US" sz="1500" dirty="0">
+              <a:rPr lang="en-US" sz="1800" b="1" dirty="0">
                 <a:solidFill>
                   <a:srgbClr val="FFFFFF"/>
                 </a:solidFill>
-                <a:latin typeface="Aptos" pitchFamily="34" charset="0"/>
-                <a:ea typeface="Aptos" pitchFamily="34" charset="-122"/>
-                <a:cs typeface="Aptos" pitchFamily="34" charset="-120"/>
-              </a:rPr>
-              <a:t>Agentnetwerken zijn technisch indrukwekkend. Maar de geloofwaardigheid zit pas in wat standhoudt onder identiteit, governance en economie.</a:t>
-            </a:r>
-            <a:endParaRPr lang="en-US" sz="1500" dirty="0"/>
-          </a:p>
-        </p:txBody>
-      </p:sp>
-      <p:sp>
-        <p:nvSpPr>
-          <p:cNvPr id="14" name="Shape 11"/>
-          <p:cNvSpPr/>
-          <p:nvPr/>
-        </p:nvSpPr>
-        <p:spPr>
-          <a:xfrm>
-            <a:off x="969264" y="5084064"/>
-            <a:ext cx="10241280" cy="694944"/>
-          </a:xfrm>
-          <a:prstGeom prst="roundRect">
-            <a:avLst>
-              <a:gd name="adj" fmla="val 7895"/>
-            </a:avLst>
-          </a:prstGeom>
-          <a:solidFill>
-            <a:srgbClr val="1C2540"/>
-          </a:solidFill>
-          <a:ln w="12700">
-            <a:solidFill>
-              <a:srgbClr val="394258"/>
-            </a:solidFill>
-            <a:prstDash val="solid"/>
-          </a:ln>
-        </p:spPr>
-      </p:sp>
-      <p:sp>
-        <p:nvSpPr>
-          <p:cNvPr id="15" name="Text 12"/>
-          <p:cNvSpPr/>
-          <p:nvPr/>
-        </p:nvSpPr>
-        <p:spPr>
-          <a:xfrm>
-            <a:off x="1188720" y="5321808"/>
-            <a:ext cx="9784080" cy="182880"/>
-          </a:xfrm>
-          <a:prstGeom prst="rect">
-            <a:avLst/>
-          </a:prstGeom>
-          <a:noFill/>
-          <a:ln/>
-        </p:spPr>
-        <p:txBody>
-          <a:bodyPr wrap="square" lIns="0" tIns="0" rIns="0" bIns="0" rtlCol="0" anchor="ctr">
-            <a:normAutofit/>
-          </a:bodyPr>
-          <a:lstStyle/>
-          <a:p>
-            <a:pPr algn="ctr" indent="0" marL="0">
-              <a:buNone/>
-            </a:pPr>
-            <a:r>
-              <a:rPr lang="en-US" sz="1100" dirty="0">
+                <a:latin typeface="Aptos Display" pitchFamily="34" charset="0"/>
+                <a:ea typeface="Aptos Display" pitchFamily="34" charset="-122"/>
+                <a:cs typeface="Aptos Display" pitchFamily="34" charset="-120"/>
+              </a:rPr>
+              <a:t>Agentnetwerken kunnen indrukwekkend ogen. Geloofwaardigheid begint pas waar identiteit, governance en economie standhouden.</a:t>
+            </a:r>
+            <a:endParaRPr lang="en-US" sz="1800" dirty="0"/>
+          </a:p>
+        </p:txBody>
+      </p:sp>
+      <p:sp>
+        <p:nvSpPr>
+          <p:cNvPr id="14" name="Text 11"/>
+          <p:cNvSpPr/>
+          <p:nvPr/>
+        </p:nvSpPr>
+        <p:spPr>
+          <a:xfrm>
+            <a:off x="713232" y="5504688"/>
+            <a:ext cx="2011680" cy="146304"/>
+          </a:xfrm>
+          <a:prstGeom prst="rect">
+            <a:avLst/>
+          </a:prstGeom>
+          <a:noFill/>
+          <a:ln/>
+        </p:spPr>
+        <p:txBody>
+          <a:bodyPr wrap="square" lIns="0" tIns="0" rIns="0" bIns="0" rtlCol="0" anchor="ctr">
+            <a:normAutofit/>
+          </a:bodyPr>
+          <a:lstStyle/>
+          <a:p>
+            <a:pPr indent="0" marL="0">
+              <a:buNone/>
+            </a:pPr>
+            <a:r>
+              <a:rPr lang="en-US" sz="900" dirty="0">
                 <a:solidFill>
                   <a:srgbClr val="D7DCE7"/>
                 </a:solidFill>
@@ -2798,9 +2775,9 @@
                 <a:ea typeface="Aptos" pitchFamily="34" charset="-122"/>
                 <a:cs typeface="Aptos" pitchFamily="34" charset="-120"/>
               </a:rPr>
-              <a:t>Gespreksvragen: welke delen van uw agentstack worden vandaag nog telkens gereconstrueerd? Waar breekt governance eerst? Welke cijfers zijn gemeten, en welke zijn nog scenario-aannames?</a:t>
-            </a:r>
-            <a:endParaRPr lang="en-US" sz="1100" dirty="0"/>
+              <a:t>Gespreksvragen in de notes</a:t>
+            </a:r>
+            <a:endParaRPr lang="en-US" sz="900" dirty="0"/>
           </a:p>
         </p:txBody>
       </p:sp>
@@ -3827,7 +3804,7 @@
                 <a:ea typeface="Aptos Display" pitchFamily="34" charset="-122"/>
                 <a:cs typeface="Aptos Display" pitchFamily="34" charset="-120"/>
               </a:rPr>
-              <a:t>Een agentnetwerk is vooral een systeem</a:t>
+              <a:t>Een agentnetwerk is een systeem, geen wezen</a:t>
             </a:r>
             <a:endParaRPr lang="en-US" sz="2300" dirty="0"/>
           </a:p>
@@ -3905,36 +3882,36 @@
         </p:nvSpPr>
         <p:spPr>
           <a:xfrm>
-            <a:off x="713232" y="1170432"/>
-            <a:ext cx="5029200" cy="219456"/>
-          </a:xfrm>
-          <a:prstGeom prst="rect">
-            <a:avLst/>
-          </a:prstGeom>
-          <a:noFill/>
-          <a:ln/>
-        </p:spPr>
-        <p:txBody>
-          <a:bodyPr wrap="square" lIns="0" tIns="0" rIns="0" bIns="0" rtlCol="0" anchor="ctr">
-            <a:normAutofit/>
-          </a:bodyPr>
-          <a:lstStyle/>
-          <a:p>
-            <a:pPr indent="0" marL="0">
-              <a:buNone/>
-            </a:pPr>
-            <a:r>
-              <a:rPr lang="en-US" sz="1500" dirty="0">
-                <a:solidFill>
-                  <a:srgbClr val="D7DCE7"/>
-                </a:solidFill>
-                <a:latin typeface="Aptos" pitchFamily="34" charset="0"/>
-                <a:ea typeface="Aptos" pitchFamily="34" charset="-122"/>
-                <a:cs typeface="Aptos" pitchFamily="34" charset="-120"/>
-              </a:rPr>
-              <a:t>De praktische definitie is niet mystiek maar operationeel.</a:t>
-            </a:r>
-            <a:endParaRPr lang="en-US" sz="1500" dirty="0"/>
+            <a:off x="713232" y="1207008"/>
+            <a:ext cx="5669280" cy="310896"/>
+          </a:xfrm>
+          <a:prstGeom prst="rect">
+            <a:avLst/>
+          </a:prstGeom>
+          <a:noFill/>
+          <a:ln/>
+        </p:spPr>
+        <p:txBody>
+          <a:bodyPr wrap="square" lIns="0" tIns="0" rIns="0" bIns="0" rtlCol="0" anchor="ctr">
+            <a:normAutofit/>
+          </a:bodyPr>
+          <a:lstStyle/>
+          <a:p>
+            <a:pPr indent="0" marL="0">
+              <a:buNone/>
+            </a:pPr>
+            <a:r>
+              <a:rPr lang="en-US" sz="1800" b="1" dirty="0">
+                <a:solidFill>
+                  <a:srgbClr val="F2AD18"/>
+                </a:solidFill>
+                <a:latin typeface="Aptos Display" pitchFamily="34" charset="0"/>
+                <a:ea typeface="Aptos Display" pitchFamily="34" charset="-122"/>
+                <a:cs typeface="Aptos Display" pitchFamily="34" charset="-120"/>
+              </a:rPr>
+              <a:t>Wat als autonomie voelt, is vaak een georkestreerde loop.</a:t>
+            </a:r>
+            <a:endParaRPr lang="en-US" sz="1800" dirty="0"/>
           </a:p>
         </p:txBody>
       </p:sp>
@@ -3946,8 +3923,8 @@
         </p:nvSpPr>
         <p:spPr>
           <a:xfrm>
-            <a:off x="713232" y="1499616"/>
-            <a:ext cx="3493008" cy="329184"/>
+            <a:off x="713232" y="1700784"/>
+            <a:ext cx="1298448" cy="329184"/>
           </a:xfrm>
           <a:prstGeom prst="roundRect">
             <a:avLst>
@@ -3955,11 +3932,11 @@
             </a:avLst>
           </a:prstGeom>
           <a:solidFill>
-            <a:srgbClr val="F2AD18"/>
+            <a:srgbClr val="E93325"/>
           </a:solidFill>
           <a:ln w="12700">
             <a:solidFill>
-              <a:srgbClr val="F2AD18">
+              <a:srgbClr val="E93325">
                 <a:alpha val="0"/>
               </a:srgbClr>
             </a:solidFill>
@@ -3975,8 +3952,8 @@
         </p:nvSpPr>
         <p:spPr>
           <a:xfrm>
-            <a:off x="859536" y="1572768"/>
-            <a:ext cx="3200400" cy="164592"/>
+            <a:off x="859536" y="1773936"/>
+            <a:ext cx="1005840" cy="164592"/>
           </a:xfrm>
           <a:prstGeom prst="rect">
             <a:avLst/>
@@ -3996,13 +3973,13 @@
             <a:r>
               <a:rPr lang="en-US" sz="900" b="1" dirty="0">
                 <a:solidFill>
-                  <a:srgbClr val="12192C"/>
-                </a:solidFill>
-                <a:latin typeface="Aptos" pitchFamily="34" charset="0"/>
-                <a:ea typeface="Aptos" pitchFamily="34" charset="-122"/>
-                <a:cs typeface="Aptos" pitchFamily="34" charset="-120"/>
-              </a:rPr>
-              <a:t>model + instructies + context + tools + state</a:t>
+                  <a:srgbClr val="FFFFFF"/>
+                </a:solidFill>
+                <a:latin typeface="Aptos" pitchFamily="34" charset="0"/>
+                <a:ea typeface="Aptos" pitchFamily="34" charset="-122"/>
+                <a:cs typeface="Aptos" pitchFamily="34" charset="-120"/>
+              </a:rPr>
+              <a:t>operationele lezing</a:t>
             </a:r>
             <a:endParaRPr lang="en-US" sz="900" dirty="0"/>
           </a:p>
@@ -4016,8 +3993,8 @@
         </p:nvSpPr>
         <p:spPr>
           <a:xfrm>
-            <a:off x="1133856" y="2907792"/>
-            <a:ext cx="9555480" cy="0"/>
+            <a:off x="1371600" y="2798064"/>
+            <a:ext cx="8138160" cy="0"/>
           </a:xfrm>
           <a:prstGeom prst="line">
             <a:avLst/>
@@ -4039,7 +4016,7 @@
         </p:nvSpPr>
         <p:spPr>
           <a:xfrm>
-            <a:off x="877824" y="2340864"/>
+            <a:off x="987552" y="2212848"/>
             <a:ext cx="1901952" cy="1005840"/>
           </a:xfrm>
           <a:prstGeom prst="roundRect">
@@ -4066,7 +4043,7 @@
         </p:nvSpPr>
         <p:spPr>
           <a:xfrm>
-            <a:off x="1024128" y="2505456"/>
+            <a:off x="1133856" y="2377440"/>
             <a:ext cx="1609344" cy="201168"/>
           </a:xfrm>
           <a:prstGeom prst="rect">
@@ -4093,7 +4070,7 @@
                 <a:ea typeface="Aptos" pitchFamily="34" charset="-122"/>
                 <a:cs typeface="Aptos" pitchFamily="34" charset="-120"/>
               </a:rPr>
-              <a:t>Instructies</a:t>
+              <a:t>Context</a:t>
             </a:r>
             <a:endParaRPr lang="en-US" sz="1400" dirty="0"/>
           </a:p>
@@ -4107,7 +4084,7 @@
         </p:nvSpPr>
         <p:spPr>
           <a:xfrm>
-            <a:off x="1024128" y="2798064"/>
+            <a:off x="1133856" y="2670048"/>
             <a:ext cx="1609344" cy="310896"/>
           </a:xfrm>
           <a:prstGeom prst="rect">
@@ -4134,7 +4111,7 @@
                 <a:ea typeface="Aptos" pitchFamily="34" charset="-122"/>
                 <a:cs typeface="Aptos" pitchFamily="34" charset="-120"/>
               </a:rPr>
-              <a:t>rol, regels,</a:t>
+              <a:t>geschiedenis,</a:t>
             </a:r>
             <a:endParaRPr lang="en-US" sz="1000" dirty="0"/>
           </a:p>
@@ -4151,10 +4128,27 @@
                 <a:ea typeface="Aptos" pitchFamily="34" charset="-122"/>
                 <a:cs typeface="Aptos" pitchFamily="34" charset="-120"/>
               </a:rPr>
-              <a:t>AGENTS.md</a:t>
+              <a:t>retrieval,</a:t>
             </a:r>
             <a:endParaRPr lang="en-US" sz="1000" dirty="0"/>
           </a:p>
+          <a:p>
+            <a:pPr indent="0" marL="0">
+              <a:buNone/>
+            </a:pPr>
+            <a:r>
+              <a:rPr lang="en-US" sz="1000" dirty="0">
+                <a:solidFill>
+                  <a:srgbClr val="D7DCE7"/>
+                </a:solidFill>
+                <a:latin typeface="Aptos" pitchFamily="34" charset="0"/>
+                <a:ea typeface="Aptos" pitchFamily="34" charset="-122"/>
+                <a:cs typeface="Aptos" pitchFamily="34" charset="-120"/>
+              </a:rPr>
+              <a:t>files</a:t>
+            </a:r>
+            <a:endParaRPr lang="en-US" sz="1000" dirty="0"/>
+          </a:p>
         </p:txBody>
       </p:sp>
       <p:sp>
@@ -4165,7 +4159,7 @@
         </p:nvSpPr>
         <p:spPr>
           <a:xfrm>
-            <a:off x="2889504" y="2340864"/>
+            <a:off x="3913632" y="2212848"/>
             <a:ext cx="1901952" cy="1005840"/>
           </a:xfrm>
           <a:prstGeom prst="roundRect">
@@ -4192,7 +4186,7 @@
         </p:nvSpPr>
         <p:spPr>
           <a:xfrm>
-            <a:off x="3035808" y="2505456"/>
+            <a:off x="4059936" y="2377440"/>
             <a:ext cx="1609344" cy="201168"/>
           </a:xfrm>
           <a:prstGeom prst="rect">
@@ -4219,7 +4213,7 @@
                 <a:ea typeface="Aptos" pitchFamily="34" charset="-122"/>
                 <a:cs typeface="Aptos" pitchFamily="34" charset="-120"/>
               </a:rPr>
-              <a:t>Context</a:t>
+              <a:t>Tools</a:t>
             </a:r>
             <a:endParaRPr lang="en-US" sz="1400" dirty="0"/>
           </a:p>
@@ -4233,7 +4227,7 @@
         </p:nvSpPr>
         <p:spPr>
           <a:xfrm>
-            <a:off x="3035808" y="2798064"/>
+            <a:off x="4059936" y="2670048"/>
             <a:ext cx="1609344" cy="310896"/>
           </a:xfrm>
           <a:prstGeom prst="rect">
@@ -4260,7 +4254,7 @@
                 <a:ea typeface="Aptos" pitchFamily="34" charset="-122"/>
                 <a:cs typeface="Aptos" pitchFamily="34" charset="-120"/>
               </a:rPr>
-              <a:t>geschiedenis,</a:t>
+              <a:t>rechten,</a:t>
             </a:r>
             <a:endParaRPr lang="en-US" sz="1000" dirty="0"/>
           </a:p>
@@ -4277,10 +4271,27 @@
                 <a:ea typeface="Aptos" pitchFamily="34" charset="-122"/>
                 <a:cs typeface="Aptos" pitchFamily="34" charset="-120"/>
               </a:rPr>
-              <a:t>retrieval, files</a:t>
+              <a:t>schema's,</a:t>
             </a:r>
             <a:endParaRPr lang="en-US" sz="1000" dirty="0"/>
           </a:p>
+          <a:p>
+            <a:pPr indent="0" marL="0">
+              <a:buNone/>
+            </a:pPr>
+            <a:r>
+              <a:rPr lang="en-US" sz="1000" dirty="0">
+                <a:solidFill>
+                  <a:srgbClr val="D7DCE7"/>
+                </a:solidFill>
+                <a:latin typeface="Aptos" pitchFamily="34" charset="0"/>
+                <a:ea typeface="Aptos" pitchFamily="34" charset="-122"/>
+                <a:cs typeface="Aptos" pitchFamily="34" charset="-120"/>
+              </a:rPr>
+              <a:t>routing</a:t>
+            </a:r>
+            <a:endParaRPr lang="en-US" sz="1000" dirty="0"/>
+          </a:p>
         </p:txBody>
       </p:sp>
       <p:sp>
@@ -4291,7 +4302,7 @@
         </p:nvSpPr>
         <p:spPr>
           <a:xfrm>
-            <a:off x="4901184" y="2340864"/>
+            <a:off x="6839712" y="2212848"/>
             <a:ext cx="1901952" cy="1005840"/>
           </a:xfrm>
           <a:prstGeom prst="roundRect">
@@ -4318,7 +4329,7 @@
         </p:nvSpPr>
         <p:spPr>
           <a:xfrm>
-            <a:off x="5047488" y="2505456"/>
+            <a:off x="6986016" y="2377440"/>
             <a:ext cx="1609344" cy="201168"/>
           </a:xfrm>
           <a:prstGeom prst="rect">
@@ -4345,7 +4356,7 @@
                 <a:ea typeface="Aptos" pitchFamily="34" charset="-122"/>
                 <a:cs typeface="Aptos" pitchFamily="34" charset="-120"/>
               </a:rPr>
-              <a:t>Tools</a:t>
+              <a:t>State</a:t>
             </a:r>
             <a:endParaRPr lang="en-US" sz="1400" dirty="0"/>
           </a:p>
@@ -4359,7 +4370,7 @@
         </p:nvSpPr>
         <p:spPr>
           <a:xfrm>
-            <a:off x="5047488" y="2798064"/>
+            <a:off x="6986016" y="2670048"/>
             <a:ext cx="1609344" cy="310896"/>
           </a:xfrm>
           <a:prstGeom prst="rect">
@@ -4386,7 +4397,7 @@
                 <a:ea typeface="Aptos" pitchFamily="34" charset="-122"/>
                 <a:cs typeface="Aptos" pitchFamily="34" charset="-120"/>
               </a:rPr>
-              <a:t>schema's,</a:t>
+              <a:t>sessies,</a:t>
             </a:r>
             <a:endParaRPr lang="en-US" sz="1000" dirty="0"/>
           </a:p>
@@ -4403,10 +4414,27 @@
                 <a:ea typeface="Aptos" pitchFamily="34" charset="-122"/>
                 <a:cs typeface="Aptos" pitchFamily="34" charset="-120"/>
               </a:rPr>
-              <a:t>rechten</a:t>
+              <a:t>externe</a:t>
             </a:r>
             <a:endParaRPr lang="en-US" sz="1000" dirty="0"/>
           </a:p>
+          <a:p>
+            <a:pPr indent="0" marL="0">
+              <a:buNone/>
+            </a:pPr>
+            <a:r>
+              <a:rPr lang="en-US" sz="1000" dirty="0">
+                <a:solidFill>
+                  <a:srgbClr val="D7DCE7"/>
+                </a:solidFill>
+                <a:latin typeface="Aptos" pitchFamily="34" charset="0"/>
+                <a:ea typeface="Aptos" pitchFamily="34" charset="-122"/>
+                <a:cs typeface="Aptos" pitchFamily="34" charset="-120"/>
+              </a:rPr>
+              <a:t>geheugenlaag</a:t>
+            </a:r>
+            <a:endParaRPr lang="en-US" sz="1000" dirty="0"/>
+          </a:p>
         </p:txBody>
       </p:sp>
       <p:sp>
@@ -4417,12 +4445,12 @@
         </p:nvSpPr>
         <p:spPr>
           <a:xfrm>
-            <a:off x="6912864" y="2340864"/>
-            <a:ext cx="1901952" cy="1005840"/>
+            <a:off x="713232" y="3950208"/>
+            <a:ext cx="6912864" cy="1426464"/>
           </a:xfrm>
           <a:prstGeom prst="roundRect">
             <a:avLst>
-              <a:gd name="adj" fmla="val 5455"/>
+              <a:gd name="adj" fmla="val 3846"/>
             </a:avLst>
           </a:prstGeom>
           <a:solidFill>
@@ -4444,8 +4472,8 @@
         </p:nvSpPr>
         <p:spPr>
           <a:xfrm>
-            <a:off x="7059168" y="2505456"/>
-            <a:ext cx="1609344" cy="201168"/>
+            <a:off x="950976" y="4242816"/>
+            <a:ext cx="2560320" cy="201168"/>
           </a:xfrm>
           <a:prstGeom prst="rect">
             <a:avLst/>
@@ -4471,7 +4499,7 @@
                 <a:ea typeface="Aptos" pitchFamily="34" charset="-122"/>
                 <a:cs typeface="Aptos" pitchFamily="34" charset="-120"/>
               </a:rPr>
-              <a:t>Model</a:t>
+              <a:t>Wat OpenClaw hier hard maakt</a:t>
             </a:r>
             <a:endParaRPr lang="en-US" sz="1400" dirty="0"/>
           </a:p>
@@ -4485,53 +4513,53 @@
         </p:nvSpPr>
         <p:spPr>
           <a:xfrm>
-            <a:off x="7059168" y="2798064"/>
-            <a:ext cx="1609344" cy="310896"/>
-          </a:xfrm>
-          <a:prstGeom prst="rect">
-            <a:avLst/>
-          </a:prstGeom>
-          <a:noFill/>
-          <a:ln/>
-        </p:spPr>
-        <p:txBody>
-          <a:bodyPr wrap="square" lIns="0" tIns="0" rIns="0" bIns="0" rtlCol="0" anchor="ctr">
-            <a:normAutofit/>
-          </a:bodyPr>
-          <a:lstStyle/>
-          <a:p>
-            <a:pPr indent="0" marL="0">
-              <a:buNone/>
-            </a:pPr>
-            <a:r>
-              <a:rPr lang="en-US" sz="1000" dirty="0">
-                <a:solidFill>
-                  <a:srgbClr val="D7DCE7"/>
-                </a:solidFill>
-                <a:latin typeface="Aptos" pitchFamily="34" charset="0"/>
-                <a:ea typeface="Aptos" pitchFamily="34" charset="-122"/>
-                <a:cs typeface="Aptos" pitchFamily="34" charset="-120"/>
-              </a:rPr>
-              <a:t>redenatie,</a:t>
-            </a:r>
-            <a:endParaRPr lang="en-US" sz="1000" dirty="0"/>
-          </a:p>
-          <a:p>
-            <a:pPr indent="0" marL="0">
-              <a:buNone/>
-            </a:pPr>
-            <a:r>
-              <a:rPr lang="en-US" sz="1000" dirty="0">
-                <a:solidFill>
-                  <a:srgbClr val="D7DCE7"/>
-                </a:solidFill>
-                <a:latin typeface="Aptos" pitchFamily="34" charset="0"/>
-                <a:ea typeface="Aptos" pitchFamily="34" charset="-122"/>
-                <a:cs typeface="Aptos" pitchFamily="34" charset="-120"/>
-              </a:rPr>
-              <a:t>output</a:t>
-            </a:r>
-            <a:endParaRPr lang="en-US" sz="1000" dirty="0"/>
+            <a:off x="950976" y="4572000"/>
+            <a:ext cx="6126480" cy="512064"/>
+          </a:xfrm>
+          <a:prstGeom prst="rect">
+            <a:avLst/>
+          </a:prstGeom>
+          <a:noFill/>
+          <a:ln/>
+        </p:spPr>
+        <p:txBody>
+          <a:bodyPr wrap="square" lIns="0" tIns="0" rIns="0" bIns="0" rtlCol="0" anchor="ctr">
+            <a:normAutofit/>
+          </a:bodyPr>
+          <a:lstStyle/>
+          <a:p>
+            <a:pPr indent="0" marL="0">
+              <a:buNone/>
+            </a:pPr>
+            <a:r>
+              <a:rPr lang="en-US" sz="1700" b="1" dirty="0">
+                <a:solidFill>
+                  <a:srgbClr val="FFFFFF"/>
+                </a:solidFill>
+                <a:latin typeface="Aptos Display" pitchFamily="34" charset="0"/>
+                <a:ea typeface="Aptos Display" pitchFamily="34" charset="-122"/>
+                <a:cs typeface="Aptos Display" pitchFamily="34" charset="-120"/>
+              </a:rPr>
+              <a:t>Multi-agent gedrag is technisch echt.</a:t>
+            </a:r>
+            <a:endParaRPr lang="en-US" sz="1700" dirty="0"/>
+          </a:p>
+          <a:p>
+            <a:pPr indent="0" marL="0">
+              <a:buNone/>
+            </a:pPr>
+            <a:r>
+              <a:rPr lang="en-US" sz="1700" b="1" dirty="0">
+                <a:solidFill>
+                  <a:srgbClr val="FFFFFF"/>
+                </a:solidFill>
+                <a:latin typeface="Aptos Display" pitchFamily="34" charset="0"/>
+                <a:ea typeface="Aptos Display" pitchFamily="34" charset="-122"/>
+                <a:cs typeface="Aptos Display" pitchFamily="34" charset="-120"/>
+              </a:rPr>
+              <a:t>Maar het blijft opgebouwd uit context, tools, policies en state.</a:t>
+            </a:r>
+            <a:endParaRPr lang="en-US" sz="1700" dirty="0"/>
           </a:p>
         </p:txBody>
       </p:sp>
@@ -4543,12 +4571,12 @@
         </p:nvSpPr>
         <p:spPr>
           <a:xfrm>
-            <a:off x="8924544" y="2340864"/>
-            <a:ext cx="1901952" cy="1005840"/>
+            <a:off x="7936992" y="1920240"/>
+            <a:ext cx="3566160" cy="3456432"/>
           </a:xfrm>
           <a:prstGeom prst="roundRect">
             <a:avLst>
-              <a:gd name="adj" fmla="val 5455"/>
+              <a:gd name="adj" fmla="val 1587"/>
             </a:avLst>
           </a:prstGeom>
           <a:solidFill>
@@ -4562,119 +4590,44 @@
           </a:ln>
         </p:spPr>
       </p:sp>
-      <p:sp>
-        <p:nvSpPr>
-          <p:cNvPr id="26" name="Text 23"/>
-          <p:cNvSpPr/>
-          <p:nvPr/>
-        </p:nvSpPr>
-        <p:spPr>
-          <a:xfrm>
-            <a:off x="9070848" y="2505456"/>
-            <a:ext cx="1609344" cy="201168"/>
-          </a:xfrm>
-          <a:prstGeom prst="rect">
-            <a:avLst/>
-          </a:prstGeom>
-          <a:noFill/>
-          <a:ln/>
-        </p:spPr>
-        <p:txBody>
-          <a:bodyPr wrap="square" lIns="0" tIns="0" rIns="0" bIns="0" rtlCol="0" anchor="ctr">
-            <a:normAutofit/>
-          </a:bodyPr>
-          <a:lstStyle/>
-          <a:p>
-            <a:pPr indent="0" marL="0">
-              <a:buNone/>
-            </a:pPr>
-            <a:r>
-              <a:rPr lang="en-US" sz="1400" b="1" dirty="0">
-                <a:solidFill>
-                  <a:srgbClr val="F2AD18"/>
-                </a:solidFill>
-                <a:latin typeface="Aptos" pitchFamily="34" charset="0"/>
-                <a:ea typeface="Aptos" pitchFamily="34" charset="-122"/>
-                <a:cs typeface="Aptos" pitchFamily="34" charset="-120"/>
-              </a:rPr>
-              <a:t>State</a:t>
-            </a:r>
-            <a:endParaRPr lang="en-US" sz="1400" dirty="0"/>
-          </a:p>
-        </p:txBody>
-      </p:sp>
-      <p:sp>
-        <p:nvSpPr>
-          <p:cNvPr id="27" name="Text 24"/>
-          <p:cNvSpPr/>
-          <p:nvPr/>
-        </p:nvSpPr>
-        <p:spPr>
-          <a:xfrm>
-            <a:off x="9070848" y="2798064"/>
-            <a:ext cx="1609344" cy="310896"/>
-          </a:xfrm>
-          <a:prstGeom prst="rect">
-            <a:avLst/>
-          </a:prstGeom>
-          <a:noFill/>
-          <a:ln/>
-        </p:spPr>
-        <p:txBody>
-          <a:bodyPr wrap="square" lIns="0" tIns="0" rIns="0" bIns="0" rtlCol="0" anchor="ctr">
-            <a:normAutofit/>
-          </a:bodyPr>
-          <a:lstStyle/>
-          <a:p>
-            <a:pPr indent="0" marL="0">
-              <a:buNone/>
-            </a:pPr>
-            <a:r>
-              <a:rPr lang="en-US" sz="1000" dirty="0">
-                <a:solidFill>
-                  <a:srgbClr val="D7DCE7"/>
-                </a:solidFill>
-                <a:latin typeface="Aptos" pitchFamily="34" charset="0"/>
-                <a:ea typeface="Aptos" pitchFamily="34" charset="-122"/>
-                <a:cs typeface="Aptos" pitchFamily="34" charset="-120"/>
-              </a:rPr>
-              <a:t>routing,</a:t>
-            </a:r>
-            <a:endParaRPr lang="en-US" sz="1000" dirty="0"/>
-          </a:p>
-          <a:p>
-            <a:pPr indent="0" marL="0">
-              <a:buNone/>
-            </a:pPr>
-            <a:r>
-              <a:rPr lang="en-US" sz="1000" dirty="0">
-                <a:solidFill>
-                  <a:srgbClr val="D7DCE7"/>
-                </a:solidFill>
-                <a:latin typeface="Aptos" pitchFamily="34" charset="0"/>
-                <a:ea typeface="Aptos" pitchFamily="34" charset="-122"/>
-                <a:cs typeface="Aptos" pitchFamily="34" charset="-120"/>
-              </a:rPr>
-              <a:t>externe geheugenlaag</a:t>
-            </a:r>
-            <a:endParaRPr lang="en-US" sz="1000" dirty="0"/>
-          </a:p>
-        </p:txBody>
-      </p:sp>
-      <p:sp>
-        <p:nvSpPr>
-          <p:cNvPr id="28" name="Shape 25"/>
-          <p:cNvSpPr/>
-          <p:nvPr/>
-        </p:nvSpPr>
-        <p:spPr>
-          <a:xfrm>
-            <a:off x="713232" y="4133088"/>
-            <a:ext cx="6547104" cy="1261872"/>
+      <p:pic>
+        <p:nvPicPr>
+          <p:cNvPr id="26" name="Image 1" descr="/home/ff/Documents/BoostMeUp/MoltBook_Sessie/assets/openclaw_context_docs.png">    </p:cNvPr>
+          <p:cNvPicPr>
+            <a:picLocks noChangeAspect="1"/>
+          </p:cNvPicPr>
+          <p:nvPr/>
+        </p:nvPicPr>
+        <p:blipFill>
+          <a:blip r:embed="rId2"/>
+          <a:stretch>
+            <a:fillRect/>
+          </a:stretch>
+        </p:blipFill>
+        <p:spPr>
+          <a:xfrm>
+            <a:off x="8046720" y="2029968"/>
+            <a:ext cx="3346704" cy="3236976"/>
+          </a:xfrm>
+          <a:prstGeom prst="rect">
+            <a:avLst/>
+          </a:prstGeom>
+        </p:spPr>
+      </p:pic>
+      <p:sp>
+        <p:nvSpPr>
+          <p:cNvPr id="27" name="Shape 23"/>
+          <p:cNvSpPr/>
+          <p:nvPr/>
+        </p:nvSpPr>
+        <p:spPr>
+          <a:xfrm>
+            <a:off x="713232" y="5504688"/>
+            <a:ext cx="10927080" cy="640080"/>
           </a:xfrm>
           <a:prstGeom prst="roundRect">
             <a:avLst>
-              <a:gd name="adj" fmla="val 4348"/>
+              <a:gd name="adj" fmla="val 11429"/>
             </a:avLst>
           </a:prstGeom>
           <a:solidFill>
@@ -4690,184 +4643,7 @@
       </p:sp>
       <p:sp>
         <p:nvSpPr>
-          <p:cNvPr id="29" name="Text 26"/>
-          <p:cNvSpPr/>
-          <p:nvPr/>
-        </p:nvSpPr>
-        <p:spPr>
-          <a:xfrm>
-            <a:off x="932688" y="4389120"/>
-            <a:ext cx="2194560" cy="201168"/>
-          </a:xfrm>
-          <a:prstGeom prst="rect">
-            <a:avLst/>
-          </a:prstGeom>
-          <a:noFill/>
-          <a:ln/>
-        </p:spPr>
-        <p:txBody>
-          <a:bodyPr wrap="square" lIns="0" tIns="0" rIns="0" bIns="0" rtlCol="0" anchor="ctr">
-            <a:normAutofit/>
-          </a:bodyPr>
-          <a:lstStyle/>
-          <a:p>
-            <a:pPr indent="0" marL="0">
-              <a:buNone/>
-            </a:pPr>
-            <a:r>
-              <a:rPr lang="en-US" sz="1400" b="1" dirty="0">
-                <a:solidFill>
-                  <a:srgbClr val="F2AD18"/>
-                </a:solidFill>
-                <a:latin typeface="Aptos" pitchFamily="34" charset="0"/>
-                <a:ea typeface="Aptos" pitchFamily="34" charset="-122"/>
-                <a:cs typeface="Aptos" pitchFamily="34" charset="-120"/>
-              </a:rPr>
-              <a:t>Wat OpenClaw expliciet toont</a:t>
-            </a:r>
-            <a:endParaRPr lang="en-US" sz="1400" dirty="0"/>
-          </a:p>
-        </p:txBody>
-      </p:sp>
-      <p:sp>
-        <p:nvSpPr>
-          <p:cNvPr id="30" name="Text 27"/>
-          <p:cNvSpPr/>
-          <p:nvPr/>
-        </p:nvSpPr>
-        <p:spPr>
-          <a:xfrm>
-            <a:off x="932688" y="4700016"/>
-            <a:ext cx="5852160" cy="512064"/>
-          </a:xfrm>
-          <a:prstGeom prst="rect">
-            <a:avLst/>
-          </a:prstGeom>
-          <a:noFill/>
-          <a:ln/>
-        </p:spPr>
-        <p:txBody>
-          <a:bodyPr wrap="square" lIns="0" tIns="0" rIns="0" bIns="0" rtlCol="0" anchor="ctr">
-            <a:normAutofit/>
-          </a:bodyPr>
-          <a:lstStyle/>
-          <a:p>
-            <a:pPr indent="0" marL="0">
-              <a:buNone/>
-            </a:pPr>
-            <a:r>
-              <a:rPr lang="en-US" sz="1400" dirty="0">
-                <a:solidFill>
-                  <a:srgbClr val="FFFFFF"/>
-                </a:solidFill>
-                <a:latin typeface="Aptos" pitchFamily="34" charset="0"/>
-                <a:ea typeface="Aptos" pitchFamily="34" charset="-122"/>
-                <a:cs typeface="Aptos" pitchFamily="34" charset="-120"/>
-              </a:rPr>
-              <a:t>Routing, sandboxes en tool policy zijn technisch echt.</a:t>
-            </a:r>
-            <a:endParaRPr lang="en-US" sz="1400" dirty="0"/>
-          </a:p>
-          <a:p>
-            <a:pPr indent="0" marL="0">
-              <a:buNone/>
-            </a:pPr>
-            <a:r>
-              <a:rPr lang="en-US" sz="1400" dirty="0">
-                <a:solidFill>
-                  <a:srgbClr val="FFFFFF"/>
-                </a:solidFill>
-                <a:latin typeface="Aptos" pitchFamily="34" charset="0"/>
-                <a:ea typeface="Aptos" pitchFamily="34" charset="-122"/>
-                <a:cs typeface="Aptos" pitchFamily="34" charset="-120"/>
-              </a:rPr>
-              <a:t>Maar multi-agent setups zijn ook token-heavy en operationeel fragiel.</a:t>
-            </a:r>
-            <a:endParaRPr lang="en-US" sz="1400" dirty="0"/>
-          </a:p>
-        </p:txBody>
-      </p:sp>
-      <p:sp>
-        <p:nvSpPr>
-          <p:cNvPr id="31" name="Shape 28"/>
-          <p:cNvSpPr/>
-          <p:nvPr/>
-        </p:nvSpPr>
-        <p:spPr>
-          <a:xfrm>
-            <a:off x="7589520" y="3858768"/>
-            <a:ext cx="3913632" cy="1920240"/>
-          </a:xfrm>
-          <a:prstGeom prst="roundRect">
-            <a:avLst>
-              <a:gd name="adj" fmla="val 2857"/>
-            </a:avLst>
-          </a:prstGeom>
-          <a:solidFill>
-            <a:srgbClr val="1C2540"/>
-          </a:solidFill>
-          <a:ln w="12700">
-            <a:solidFill>
-              <a:srgbClr val="394258"/>
-            </a:solidFill>
-            <a:prstDash val="solid"/>
-          </a:ln>
-        </p:spPr>
-      </p:sp>
-      <p:pic>
-        <p:nvPicPr>
-          <p:cNvPr id="32" name="Image 1" descr="/home/ff/Documents/BoostMeUp/MoltBook_Sessie/assets/openclaw_context_docs.png">    </p:cNvPr>
-          <p:cNvPicPr>
-            <a:picLocks noChangeAspect="1"/>
-          </p:cNvPicPr>
-          <p:nvPr/>
-        </p:nvPicPr>
-        <p:blipFill>
-          <a:blip r:embed="rId2"/>
-          <a:stretch>
-            <a:fillRect/>
-          </a:stretch>
-        </p:blipFill>
-        <p:spPr>
-          <a:xfrm>
-            <a:off x="7699248" y="3968496"/>
-            <a:ext cx="3694176" cy="1700784"/>
-          </a:xfrm>
-          <a:prstGeom prst="rect">
-            <a:avLst/>
-          </a:prstGeom>
-        </p:spPr>
-      </p:pic>
-      <p:sp>
-        <p:nvSpPr>
-          <p:cNvPr id="33" name="Shape 29"/>
-          <p:cNvSpPr/>
-          <p:nvPr/>
-        </p:nvSpPr>
-        <p:spPr>
-          <a:xfrm>
-            <a:off x="713232" y="5504688"/>
-            <a:ext cx="10927080" cy="640080"/>
-          </a:xfrm>
-          <a:prstGeom prst="roundRect">
-            <a:avLst>
-              <a:gd name="adj" fmla="val 11429"/>
-            </a:avLst>
-          </a:prstGeom>
-          <a:solidFill>
-            <a:srgbClr val="1C2540"/>
-          </a:solidFill>
-          <a:ln w="12700">
-            <a:solidFill>
-              <a:srgbClr val="394258"/>
-            </a:solidFill>
-            <a:prstDash val="solid"/>
-          </a:ln>
-        </p:spPr>
-      </p:sp>
-      <p:sp>
-        <p:nvSpPr>
-          <p:cNvPr id="34" name="Text 30"/>
+          <p:cNvPr id="28" name="Text 24"/>
           <p:cNvSpPr/>
           <p:nvPr/>
         </p:nvSpPr>
@@ -4900,7 +4676,7 @@
                 <a:ea typeface="Aptos" pitchFamily="34" charset="-122"/>
                 <a:cs typeface="Aptos" pitchFamily="34" charset="-120"/>
               </a:rPr>
-              <a:t>Takeaway: dit is een architectuurverhaal, geen bewijs van één stabiel digitaal organisme.</a:t>
+              <a:t>Takeaway: architectuur is zichtbaar. Een autonoom digitaal organisme nog niet.</a:t>
             </a:r>
             <a:endParaRPr lang="en-US" sz="1200" dirty="0"/>
           </a:p>
@@ -5169,11 +4945,11 @@
         <p:spPr>
           <a:xfrm>
             <a:off x="713232" y="1261872"/>
-            <a:ext cx="4187952" cy="4462272"/>
+            <a:ext cx="3858768" cy="4279392"/>
           </a:xfrm>
           <a:prstGeom prst="roundRect">
             <a:avLst>
-              <a:gd name="adj" fmla="val 1310"/>
+              <a:gd name="adj" fmla="val 1422"/>
             </a:avLst>
           </a:prstGeom>
           <a:solidFill>
@@ -5265,26 +5041,26 @@
         </p:nvSpPr>
         <p:spPr>
           <a:xfrm>
-            <a:off x="914400" y="2011680"/>
-            <a:ext cx="2743200" cy="713232"/>
-          </a:xfrm>
-          <a:prstGeom prst="rect">
-            <a:avLst/>
-          </a:prstGeom>
-          <a:noFill/>
-          <a:ln/>
-        </p:spPr>
-        <p:txBody>
-          <a:bodyPr wrap="square" lIns="0" tIns="0" rIns="0" bIns="0" rtlCol="0" anchor="ctr">
-            <a:normAutofit/>
-          </a:bodyPr>
-          <a:lstStyle/>
-          <a:p>
-            <a:pPr indent="0" marL="0">
-              <a:buNone/>
-            </a:pPr>
-            <a:r>
-              <a:rPr lang="en-US" sz="4200" b="1" dirty="0">
+            <a:off x="932688" y="1828800"/>
+            <a:ext cx="2560320" cy="749808"/>
+          </a:xfrm>
+          <a:prstGeom prst="rect">
+            <a:avLst/>
+          </a:prstGeom>
+          <a:noFill/>
+          <a:ln/>
+        </p:spPr>
+        <p:txBody>
+          <a:bodyPr wrap="square" lIns="0" tIns="0" rIns="0" bIns="0" rtlCol="0" anchor="ctr">
+            <a:normAutofit/>
+          </a:bodyPr>
+          <a:lstStyle/>
+          <a:p>
+            <a:pPr indent="0" marL="0">
+              <a:buNone/>
+            </a:pPr>
+            <a:r>
+              <a:rPr lang="en-US" sz="4800" b="1" dirty="0">
                 <a:solidFill>
                   <a:srgbClr val="E93325"/>
                 </a:solidFill>
@@ -5294,7 +5070,7 @@
               </a:rPr>
               <a:t>87%</a:t>
             </a:r>
-            <a:endParaRPr lang="en-US" sz="4200" dirty="0"/>
+            <a:endParaRPr lang="en-US" sz="4800" dirty="0"/>
           </a:p>
         </p:txBody>
       </p:sp>
@@ -5306,67 +5082,26 @@
         </p:nvSpPr>
         <p:spPr>
           <a:xfrm>
-            <a:off x="932688" y="2761488"/>
-            <a:ext cx="3291840" cy="548640"/>
-          </a:xfrm>
-          <a:prstGeom prst="rect">
-            <a:avLst/>
-          </a:prstGeom>
-          <a:noFill/>
-          <a:ln/>
-        </p:spPr>
-        <p:txBody>
-          <a:bodyPr wrap="square" lIns="0" tIns="0" rIns="0" bIns="0" rtlCol="0" anchor="ctr">
-            <a:normAutofit/>
-          </a:bodyPr>
-          <a:lstStyle/>
-          <a:p>
-            <a:pPr indent="0" marL="0">
-              <a:buNone/>
-            </a:pPr>
-            <a:r>
-              <a:rPr lang="en-US" sz="1800" b="1" dirty="0">
-                <a:solidFill>
-                  <a:srgbClr val="12192C"/>
-                </a:solidFill>
-                <a:latin typeface="Aptos" pitchFamily="34" charset="0"/>
-                <a:ea typeface="Aptos" pitchFamily="34" charset="-122"/>
-                <a:cs typeface="Aptos" pitchFamily="34" charset="-120"/>
-              </a:rPr>
-              <a:t>van de totale cyclus zit in het herladen van context</a:t>
-            </a:r>
-            <a:endParaRPr lang="en-US" sz="1800" dirty="0"/>
-          </a:p>
-        </p:txBody>
-      </p:sp>
-      <p:sp>
-        <p:nvSpPr>
-          <p:cNvPr id="14" name="Text 11"/>
-          <p:cNvSpPr/>
-          <p:nvPr/>
-        </p:nvSpPr>
-        <p:spPr>
-          <a:xfrm>
-            <a:off x="932688" y="3730752"/>
-            <a:ext cx="3566160" cy="310896"/>
-          </a:xfrm>
-          <a:prstGeom prst="rect">
-            <a:avLst/>
-          </a:prstGeom>
-          <a:noFill/>
-          <a:ln/>
-        </p:spPr>
-        <p:txBody>
-          <a:bodyPr wrap="square" lIns="0" tIns="0" rIns="0" bIns="0" rtlCol="0" anchor="ctr">
-            <a:normAutofit/>
-          </a:bodyPr>
-          <a:lstStyle/>
-          <a:p>
-            <a:pPr indent="0" marL="0">
-              <a:buNone/>
-            </a:pPr>
-            <a:r>
-              <a:rPr lang="en-US" sz="1800" b="1" dirty="0">
+            <a:off x="932688" y="2724912"/>
+            <a:ext cx="2926080" cy="493776"/>
+          </a:xfrm>
+          <a:prstGeom prst="rect">
+            <a:avLst/>
+          </a:prstGeom>
+          <a:noFill/>
+          <a:ln/>
+        </p:spPr>
+        <p:txBody>
+          <a:bodyPr wrap="square" lIns="0" tIns="0" rIns="0" bIns="0" rtlCol="0" anchor="ctr">
+            <a:normAutofit/>
+          </a:bodyPr>
+          <a:lstStyle/>
+          <a:p>
+            <a:pPr indent="0" marL="0">
+              <a:buNone/>
+            </a:pPr>
+            <a:r>
+              <a:rPr lang="en-US" sz="2000" b="1" dirty="0">
                 <a:solidFill>
                   <a:srgbClr val="12192C"/>
                 </a:solidFill>
@@ -5374,9 +5109,50 @@
                 <a:ea typeface="Aptos Display" pitchFamily="34" charset="-122"/>
                 <a:cs typeface="Aptos Display" pitchFamily="34" charset="-120"/>
               </a:rPr>
-              <a:t>$0,377 per read-reply-post-cyclus op Opus 4.6</a:t>
-            </a:r>
-            <a:endParaRPr lang="en-US" sz="1800" dirty="0"/>
+              <a:t>van de illustratieve cyclus zit in context reload</a:t>
+            </a:r>
+            <a:endParaRPr lang="en-US" sz="2000" dirty="0"/>
+          </a:p>
+        </p:txBody>
+      </p:sp>
+      <p:sp>
+        <p:nvSpPr>
+          <p:cNvPr id="14" name="Text 11"/>
+          <p:cNvSpPr/>
+          <p:nvPr/>
+        </p:nvSpPr>
+        <p:spPr>
+          <a:xfrm>
+            <a:off x="932688" y="3822192"/>
+            <a:ext cx="2926080" cy="310896"/>
+          </a:xfrm>
+          <a:prstGeom prst="rect">
+            <a:avLst/>
+          </a:prstGeom>
+          <a:noFill/>
+          <a:ln/>
+        </p:spPr>
+        <p:txBody>
+          <a:bodyPr wrap="square" lIns="0" tIns="0" rIns="0" bIns="0" rtlCol="0" anchor="ctr">
+            <a:normAutofit/>
+          </a:bodyPr>
+          <a:lstStyle/>
+          <a:p>
+            <a:pPr indent="0" marL="0">
+              <a:buNone/>
+            </a:pPr>
+            <a:r>
+              <a:rPr lang="en-US" sz="2100" b="1" dirty="0">
+                <a:solidFill>
+                  <a:srgbClr val="12192C"/>
+                </a:solidFill>
+                <a:latin typeface="Aptos Display" pitchFamily="34" charset="0"/>
+                <a:ea typeface="Aptos Display" pitchFamily="34" charset="-122"/>
+                <a:cs typeface="Aptos Display" pitchFamily="34" charset="-120"/>
+              </a:rPr>
+              <a:t>$0,377 per read-reply-post-cyclus</a:t>
+            </a:r>
+            <a:endParaRPr lang="en-US" sz="2100" dirty="0"/>
           </a:p>
         </p:txBody>
       </p:sp>
@@ -5388,8 +5164,8 @@
         </p:nvSpPr>
         <p:spPr>
           <a:xfrm>
-            <a:off x="932688" y="4169664"/>
-            <a:ext cx="3291840" cy="256032"/>
+            <a:off x="932688" y="4187952"/>
+            <a:ext cx="2926080" cy="219456"/>
           </a:xfrm>
           <a:prstGeom prst="rect">
             <a:avLst/>
@@ -5415,7 +5191,7 @@
                 <a:ea typeface="Aptos" pitchFamily="34" charset="-122"/>
                 <a:cs typeface="Aptos" pitchFamily="34" charset="-120"/>
               </a:rPr>
-              <a:t>Dat bedrag komt uit expliciete aannames in deze repo.</a:t>
+              <a:t>op Claude Opus 4.6, onder repo-aannames</a:t>
             </a:r>
             <a:endParaRPr lang="en-US" sz="1200" dirty="0"/>
           </a:p>
@@ -5429,12 +5205,12 @@
         </p:nvSpPr>
         <p:spPr>
           <a:xfrm>
-            <a:off x="5175504" y="1261872"/>
-            <a:ext cx="6236208" cy="4462272"/>
+            <a:off x="4828032" y="1261872"/>
+            <a:ext cx="6583680" cy="4279392"/>
           </a:xfrm>
           <a:prstGeom prst="roundRect">
             <a:avLst>
-              <a:gd name="adj" fmla="val 1230"/>
+              <a:gd name="adj" fmla="val 1282"/>
             </a:avLst>
           </a:prstGeom>
           <a:solidFill>
@@ -5456,8 +5232,8 @@
         </p:nvSpPr>
         <p:spPr>
           <a:xfrm>
-            <a:off x="5449824" y="1554480"/>
-            <a:ext cx="3108960" cy="219456"/>
+            <a:off x="5102352" y="1572768"/>
+            <a:ext cx="2011680" cy="219456"/>
           </a:xfrm>
           <a:prstGeom prst="rect">
             <a:avLst/>
@@ -5483,7 +5259,7 @@
                 <a:ea typeface="Aptos" pitchFamily="34" charset="-122"/>
                 <a:cs typeface="Aptos" pitchFamily="34" charset="-120"/>
               </a:rPr>
-              <a:t>Waar de tokens echt naartoe gaan</a:t>
+              <a:t>Eén groot verschil</a:t>
             </a:r>
             <a:endParaRPr lang="en-US" sz="1600" dirty="0"/>
           </a:p>
@@ -5497,8 +5273,8 @@
         </p:nvSpPr>
         <p:spPr>
           <a:xfrm>
-            <a:off x="5449824" y="1956816"/>
-            <a:ext cx="5303520" cy="182880"/>
+            <a:off x="5102352" y="2066544"/>
+            <a:ext cx="5486400" cy="182880"/>
           </a:xfrm>
           <a:prstGeom prst="rect">
             <a:avLst/>
@@ -5524,7 +5300,7 @@
                 <a:ea typeface="Aptos" pitchFamily="34" charset="-122"/>
                 <a:cs typeface="Aptos" pitchFamily="34" charset="-120"/>
               </a:rPr>
-              <a:t>Context laden (3x)</a:t>
+              <a:t>Context reload (3x)</a:t>
             </a:r>
             <a:endParaRPr lang="en-US" sz="1100" dirty="0"/>
           </a:p>
@@ -5538,8 +5314,8 @@
         </p:nvSpPr>
         <p:spPr>
           <a:xfrm>
-            <a:off x="5449824" y="2194560"/>
-            <a:ext cx="5303520" cy="237744"/>
+            <a:off x="5102352" y="2304288"/>
+            <a:ext cx="5486400" cy="237744"/>
           </a:xfrm>
           <a:prstGeom prst="roundRect">
             <a:avLst>
@@ -5567,8 +5343,8 @@
         </p:nvSpPr>
         <p:spPr>
           <a:xfrm>
-            <a:off x="5449824" y="2194560"/>
-            <a:ext cx="4614062" cy="237744"/>
+            <a:off x="5102352" y="2304288"/>
+            <a:ext cx="4773168" cy="237744"/>
           </a:xfrm>
           <a:prstGeom prst="roundRect">
             <a:avLst>
@@ -5596,7 +5372,7 @@
         </p:nvSpPr>
         <p:spPr>
           <a:xfrm>
-            <a:off x="9930384" y="1975104"/>
+            <a:off x="9765792" y="2084832"/>
             <a:ext cx="822960" cy="164592"/>
           </a:xfrm>
           <a:prstGeom prst="rect">
@@ -5623,7 +5399,7 @@
                 <a:ea typeface="Aptos" pitchFamily="34" charset="-122"/>
                 <a:cs typeface="Aptos" pitchFamily="34" charset="-120"/>
               </a:rPr>
-              <a:t>60.900</a:t>
+              <a:t>60.900 tokens</a:t>
             </a:r>
             <a:endParaRPr lang="en-US" sz="1100" dirty="0"/>
           </a:p>
@@ -5637,8 +5413,8 @@
         </p:nvSpPr>
         <p:spPr>
           <a:xfrm>
-            <a:off x="5449824" y="2688336"/>
-            <a:ext cx="5303520" cy="182880"/>
+            <a:off x="5102352" y="2962656"/>
+            <a:ext cx="5486400" cy="182880"/>
           </a:xfrm>
           <a:prstGeom prst="rect">
             <a:avLst/>
@@ -5664,7 +5440,7 @@
                 <a:ea typeface="Aptos" pitchFamily="34" charset="-122"/>
                 <a:cs typeface="Aptos" pitchFamily="34" charset="-120"/>
               </a:rPr>
-              <a:t>Timeline + reply + post</a:t>
+              <a:t>Alles daarbuiten</a:t>
             </a:r>
             <a:endParaRPr lang="en-US" sz="1100" dirty="0"/>
           </a:p>
@@ -5678,8 +5454,8 @@
         </p:nvSpPr>
         <p:spPr>
           <a:xfrm>
-            <a:off x="5449824" y="2926080"/>
-            <a:ext cx="5303520" cy="237744"/>
+            <a:off x="5102352" y="3200400"/>
+            <a:ext cx="5486400" cy="237744"/>
           </a:xfrm>
           <a:prstGeom prst="roundRect">
             <a:avLst>
@@ -5707,8 +5483,8 @@
         </p:nvSpPr>
         <p:spPr>
           <a:xfrm>
-            <a:off x="5449824" y="2926080"/>
-            <a:ext cx="689458" cy="237744"/>
+            <a:off x="5102352" y="3200400"/>
+            <a:ext cx="713232" cy="237744"/>
           </a:xfrm>
           <a:prstGeom prst="roundRect">
             <a:avLst>
@@ -5736,7 +5512,7 @@
         </p:nvSpPr>
         <p:spPr>
           <a:xfrm>
-            <a:off x="9930384" y="2706624"/>
+            <a:off x="9765792" y="2980944"/>
             <a:ext cx="822960" cy="164592"/>
           </a:xfrm>
           <a:prstGeom prst="rect">
@@ -5763,7 +5539,7 @@
                 <a:ea typeface="Aptos" pitchFamily="34" charset="-122"/>
                 <a:cs typeface="Aptos" pitchFamily="34" charset="-120"/>
               </a:rPr>
-              <a:t>8.900</a:t>
+              <a:t>8.900 tokens</a:t>
             </a:r>
             <a:endParaRPr lang="en-US" sz="1100" dirty="0"/>
           </a:p>
@@ -5777,26 +5553,125 @@
         </p:nvSpPr>
         <p:spPr>
           <a:xfrm>
-            <a:off x="5449824" y="3419856"/>
-            <a:ext cx="5303520" cy="182880"/>
-          </a:xfrm>
-          <a:prstGeom prst="rect">
-            <a:avLst/>
-          </a:prstGeom>
-          <a:noFill/>
-          <a:ln/>
-        </p:spPr>
-        <p:txBody>
-          <a:bodyPr wrap="square" lIns="0" tIns="0" rIns="0" bIns="0" rtlCol="0" anchor="ctr">
-            <a:normAutofit/>
-          </a:bodyPr>
-          <a:lstStyle/>
-          <a:p>
-            <a:pPr indent="0" marL="0">
-              <a:buNone/>
-            </a:pPr>
-            <a:r>
-              <a:rPr lang="en-US" sz="1100" b="1" dirty="0">
+            <a:off x="5102352" y="3840480"/>
+            <a:ext cx="1463040" cy="182880"/>
+          </a:xfrm>
+          <a:prstGeom prst="rect">
+            <a:avLst/>
+          </a:prstGeom>
+          <a:noFill/>
+          <a:ln/>
+        </p:spPr>
+        <p:txBody>
+          <a:bodyPr wrap="square" lIns="0" tIns="0" rIns="0" bIns="0" rtlCol="0" anchor="ctr">
+            <a:normAutofit/>
+          </a:bodyPr>
+          <a:lstStyle/>
+          <a:p>
+            <a:pPr indent="0" marL="0">
+              <a:buNone/>
+            </a:pPr>
+            <a:r>
+              <a:rPr lang="en-US" sz="1400" b="1" dirty="0">
+                <a:solidFill>
+                  <a:srgbClr val="E93325"/>
+                </a:solidFill>
+                <a:latin typeface="Aptos" pitchFamily="34" charset="0"/>
+                <a:ea typeface="Aptos" pitchFamily="34" charset="-122"/>
+                <a:cs typeface="Aptos" pitchFamily="34" charset="-120"/>
+              </a:rPr>
+              <a:t>De live-les</a:t>
+            </a:r>
+            <a:endParaRPr lang="en-US" sz="1400" dirty="0"/>
+          </a:p>
+        </p:txBody>
+      </p:sp>
+      <p:sp>
+        <p:nvSpPr>
+          <p:cNvPr id="27" name="Text 24"/>
+          <p:cNvSpPr/>
+          <p:nvPr/>
+        </p:nvSpPr>
+        <p:spPr>
+          <a:xfrm>
+            <a:off x="5102352" y="4133088"/>
+            <a:ext cx="5669280" cy="694944"/>
+          </a:xfrm>
+          <a:prstGeom prst="rect">
+            <a:avLst/>
+          </a:prstGeom>
+          <a:noFill/>
+          <a:ln/>
+        </p:spPr>
+        <p:txBody>
+          <a:bodyPr wrap="square" lIns="0" tIns="0" rIns="0" bIns="0" rtlCol="0" anchor="ctr">
+            <a:normAutofit/>
+          </a:bodyPr>
+          <a:lstStyle/>
+          <a:p>
+            <a:pPr indent="0" marL="0">
+              <a:buNone/>
+            </a:pPr>
+            <a:r>
+              <a:rPr lang="en-US" sz="1900" b="1" dirty="0">
+                <a:solidFill>
+                  <a:srgbClr val="12192C"/>
+                </a:solidFill>
+                <a:latin typeface="Aptos Display" pitchFamily="34" charset="0"/>
+                <a:ea typeface="Aptos Display" pitchFamily="34" charset="-122"/>
+                <a:cs typeface="Aptos Display" pitchFamily="34" charset="-120"/>
+              </a:rPr>
+              <a:t>Niet de reply domineert de kost.</a:t>
+            </a:r>
+            <a:endParaRPr lang="en-US" sz="1900" dirty="0"/>
+          </a:p>
+          <a:p>
+            <a:pPr indent="0" marL="0">
+              <a:buNone/>
+            </a:pPr>
+            <a:r>
+              <a:rPr lang="en-US" sz="1900" b="1" dirty="0">
+                <a:solidFill>
+                  <a:srgbClr val="12192C"/>
+                </a:solidFill>
+                <a:latin typeface="Aptos Display" pitchFamily="34" charset="0"/>
+                <a:ea typeface="Aptos Display" pitchFamily="34" charset="-122"/>
+                <a:cs typeface="Aptos Display" pitchFamily="34" charset="-120"/>
+              </a:rPr>
+              <a:t>Het is het telkens opnieuw laden van systeemcontext, instructies en geschiedenis.</a:t>
+            </a:r>
+            <a:endParaRPr lang="en-US" sz="1900" dirty="0"/>
+          </a:p>
+        </p:txBody>
+      </p:sp>
+      <p:sp>
+        <p:nvSpPr>
+          <p:cNvPr id="28" name="Text 25"/>
+          <p:cNvSpPr/>
+          <p:nvPr/>
+        </p:nvSpPr>
+        <p:spPr>
+          <a:xfrm>
+            <a:off x="5102352" y="5084064"/>
+            <a:ext cx="2377440" cy="146304"/>
+          </a:xfrm>
+          <a:prstGeom prst="rect">
+            <a:avLst/>
+          </a:prstGeom>
+          <a:noFill/>
+          <a:ln/>
+        </p:spPr>
+        <p:txBody>
+          <a:bodyPr wrap="square" lIns="0" tIns="0" rIns="0" bIns="0" rtlCol="0" anchor="ctr">
+            <a:normAutofit/>
+          </a:bodyPr>
+          <a:lstStyle/>
+          <a:p>
+            <a:pPr indent="0" marL="0">
+              <a:buNone/>
+            </a:pPr>
+            <a:r>
+              <a:rPr lang="en-US" sz="900" b="1" dirty="0">
                 <a:solidFill>
                   <a:srgbClr val="5B6476"/>
                 </a:solidFill>
@@ -5804,196 +5679,15 @@
                 <a:ea typeface="Aptos" pitchFamily="34" charset="-122"/>
                 <a:cs typeface="Aptos" pitchFamily="34" charset="-120"/>
               </a:rPr>
-              <a:t>OpenClaw docs voorbeeld</a:t>
-            </a:r>
-            <a:endParaRPr lang="en-US" sz="1100" dirty="0"/>
-          </a:p>
-        </p:txBody>
-      </p:sp>
-      <p:sp>
-        <p:nvSpPr>
-          <p:cNvPr id="27" name="Shape 24"/>
-          <p:cNvSpPr/>
-          <p:nvPr/>
-        </p:nvSpPr>
-        <p:spPr>
-          <a:xfrm>
-            <a:off x="5449824" y="3657600"/>
-            <a:ext cx="5303520" cy="237744"/>
-          </a:xfrm>
-          <a:prstGeom prst="roundRect">
-            <a:avLst>
-              <a:gd name="adj" fmla="val 30769"/>
-            </a:avLst>
-          </a:prstGeom>
-          <a:solidFill>
-            <a:srgbClr val="EEF2F7"/>
-          </a:solidFill>
-          <a:ln w="12700">
-            <a:solidFill>
-              <a:srgbClr val="EEF2F7">
-                <a:alpha val="0"/>
-              </a:srgbClr>
-            </a:solidFill>
-            <a:prstDash val="solid"/>
-          </a:ln>
-        </p:spPr>
-      </p:sp>
-      <p:sp>
-        <p:nvSpPr>
-          <p:cNvPr id="28" name="Shape 25"/>
-          <p:cNvSpPr/>
-          <p:nvPr/>
-        </p:nvSpPr>
-        <p:spPr>
-          <a:xfrm>
-            <a:off x="5449824" y="3657600"/>
-            <a:ext cx="1060704" cy="237744"/>
-          </a:xfrm>
-          <a:prstGeom prst="roundRect">
-            <a:avLst>
-              <a:gd name="adj" fmla="val 30769"/>
-            </a:avLst>
-          </a:prstGeom>
-          <a:solidFill>
-            <a:srgbClr val="0F766E"/>
-          </a:solidFill>
-          <a:ln w="12700">
-            <a:solidFill>
-              <a:srgbClr val="0F766E">
-                <a:alpha val="0"/>
-              </a:srgbClr>
-            </a:solidFill>
-            <a:prstDash val="solid"/>
-          </a:ln>
-        </p:spPr>
-      </p:sp>
-      <p:sp>
-        <p:nvSpPr>
-          <p:cNvPr id="29" name="Text 26"/>
-          <p:cNvSpPr/>
-          <p:nvPr/>
-        </p:nvSpPr>
-        <p:spPr>
-          <a:xfrm>
-            <a:off x="9930384" y="3438144"/>
-            <a:ext cx="822960" cy="164592"/>
-          </a:xfrm>
-          <a:prstGeom prst="rect">
-            <a:avLst/>
-          </a:prstGeom>
-          <a:noFill/>
-          <a:ln/>
-        </p:spPr>
-        <p:txBody>
-          <a:bodyPr wrap="square" lIns="0" tIns="0" rIns="0" bIns="0" rtlCol="0" anchor="ctr">
-            <a:normAutofit/>
-          </a:bodyPr>
-          <a:lstStyle/>
-          <a:p>
-            <a:pPr algn="r" indent="0" marL="0">
-              <a:buNone/>
-            </a:pPr>
-            <a:r>
-              <a:rPr lang="en-US" sz="1100" b="1" dirty="0">
-                <a:solidFill>
-                  <a:srgbClr val="12192C"/>
-                </a:solidFill>
-                <a:latin typeface="Aptos" pitchFamily="34" charset="0"/>
-                <a:ea typeface="Aptos" pitchFamily="34" charset="-122"/>
-                <a:cs typeface="Aptos" pitchFamily="34" charset="-120"/>
-              </a:rPr>
-              <a:t>~14.250</a:t>
-            </a:r>
-            <a:endParaRPr lang="en-US" sz="1100" dirty="0"/>
-          </a:p>
-        </p:txBody>
-      </p:sp>
-      <p:sp>
-        <p:nvSpPr>
-          <p:cNvPr id="30" name="Text 27"/>
-          <p:cNvSpPr/>
-          <p:nvPr/>
-        </p:nvSpPr>
-        <p:spPr>
-          <a:xfrm>
-            <a:off x="5449824" y="4133088"/>
-            <a:ext cx="1645920" cy="201168"/>
-          </a:xfrm>
-          <a:prstGeom prst="rect">
-            <a:avLst/>
-          </a:prstGeom>
-          <a:noFill/>
-          <a:ln/>
-        </p:spPr>
-        <p:txBody>
-          <a:bodyPr wrap="square" lIns="0" tIns="0" rIns="0" bIns="0" rtlCol="0" anchor="ctr">
-            <a:normAutofit/>
-          </a:bodyPr>
-          <a:lstStyle/>
-          <a:p>
-            <a:pPr indent="0" marL="0">
-              <a:buNone/>
-            </a:pPr>
-            <a:r>
-              <a:rPr lang="en-US" sz="1400" b="1" dirty="0">
-                <a:solidFill>
-                  <a:srgbClr val="E93325"/>
-                </a:solidFill>
-                <a:latin typeface="Aptos" pitchFamily="34" charset="0"/>
-                <a:ea typeface="Aptos" pitchFamily="34" charset="-122"/>
-                <a:cs typeface="Aptos" pitchFamily="34" charset="-120"/>
-              </a:rPr>
-              <a:t>Interpretatie</a:t>
-            </a:r>
-            <a:endParaRPr lang="en-US" sz="1400" dirty="0"/>
-          </a:p>
-        </p:txBody>
-      </p:sp>
-      <p:sp>
-        <p:nvSpPr>
-          <p:cNvPr id="31" name="Text 28"/>
-          <p:cNvSpPr/>
-          <p:nvPr/>
-        </p:nvSpPr>
-        <p:spPr>
-          <a:xfrm>
-            <a:off x="5449824" y="4443984"/>
-            <a:ext cx="5394960" cy="658368"/>
-          </a:xfrm>
-          <a:prstGeom prst="rect">
-            <a:avLst/>
-          </a:prstGeom>
-          <a:noFill/>
-          <a:ln/>
-        </p:spPr>
-        <p:txBody>
-          <a:bodyPr wrap="square" lIns="0" tIns="0" rIns="0" bIns="0" rtlCol="0" anchor="ctr">
-            <a:normAutofit/>
-          </a:bodyPr>
-          <a:lstStyle/>
-          <a:p>
-            <a:pPr indent="0" marL="0">
-              <a:buNone/>
-            </a:pPr>
-            <a:r>
-              <a:rPr lang="en-US" sz="1400" dirty="0">
-                <a:solidFill>
-                  <a:srgbClr val="12192C"/>
-                </a:solidFill>
-                <a:latin typeface="Aptos" pitchFamily="34" charset="0"/>
-                <a:ea typeface="Aptos" pitchFamily="34" charset="-122"/>
-                <a:cs typeface="Aptos" pitchFamily="34" charset="-120"/>
-              </a:rPr>
-              <a:t>De kost zit hier niet in één slimme reply. Ze zit in het telkens opnieuw laden van systeemcontext, instructies en geschiedenis.</a:t>
-            </a:r>
-            <a:endParaRPr lang="en-US" sz="1400" dirty="0"/>
-          </a:p>
-        </p:txBody>
-      </p:sp>
-      <p:sp>
-        <p:nvSpPr>
-          <p:cNvPr id="32" name="Shape 29"/>
+              <a:t>OpenClaw anchor: ~14.250 sessietokens in docsvoorbeeld</a:t>
+            </a:r>
+            <a:endParaRPr lang="en-US" sz="900" dirty="0"/>
+          </a:p>
+        </p:txBody>
+      </p:sp>
+      <p:sp>
+        <p:nvSpPr>
+          <p:cNvPr id="29" name="Shape 26"/>
           <p:cNvSpPr/>
           <p:nvPr/>
         </p:nvSpPr>
@@ -6020,7 +5714,7 @@
       </p:sp>
       <p:sp>
         <p:nvSpPr>
-          <p:cNvPr id="33" name="Text 30"/>
+          <p:cNvPr id="30" name="Text 27"/>
           <p:cNvSpPr/>
           <p:nvPr/>
         </p:nvSpPr>
@@ -6053,7 +5747,7 @@
                 <a:ea typeface="Aptos" pitchFamily="34" charset="-122"/>
                 <a:cs typeface="Aptos" pitchFamily="34" charset="-120"/>
               </a:rPr>
-              <a:t>Takeaway: kostdruk is echt; het headline-getal blijft een scenario-uitkomst, geen observatie.</a:t>
+              <a:t>Takeaway: kostdruk is echt; het getal blijft scenario-uitkomst, geen observatie.</a:t>
             </a:r>
             <a:endParaRPr lang="en-US" sz="1200" dirty="0"/>
           </a:p>
@@ -7373,18 +7067,59 @@
       </p:sp>
       <p:sp>
         <p:nvSpPr>
-          <p:cNvPr id="9" name="Shape 6"/>
-          <p:cNvSpPr/>
-          <p:nvPr/>
-        </p:nvSpPr>
-        <p:spPr>
-          <a:xfrm>
-            <a:off x="713232" y="1225296"/>
-            <a:ext cx="7543800" cy="4535424"/>
+          <p:cNvPr id="9" name="Text 6"/>
+          <p:cNvSpPr/>
+          <p:nvPr/>
+        </p:nvSpPr>
+        <p:spPr>
+          <a:xfrm>
+            <a:off x="713232" y="1170432"/>
+            <a:ext cx="7863840" cy="274320"/>
+          </a:xfrm>
+          <a:prstGeom prst="rect">
+            <a:avLst/>
+          </a:prstGeom>
+          <a:noFill/>
+          <a:ln/>
+        </p:spPr>
+        <p:txBody>
+          <a:bodyPr wrap="square" lIns="0" tIns="0" rIns="0" bIns="0" rtlCol="0" anchor="ctr">
+            <a:normAutofit/>
+          </a:bodyPr>
+          <a:lstStyle/>
+          <a:p>
+            <a:pPr indent="0" marL="0">
+              <a:buNone/>
+            </a:pPr>
+            <a:r>
+              <a:rPr lang="en-US" sz="1700" b="1" dirty="0">
+                <a:solidFill>
+                  <a:srgbClr val="12192C"/>
+                </a:solidFill>
+                <a:latin typeface="Aptos Display" pitchFamily="34" charset="0"/>
+                <a:ea typeface="Aptos Display" pitchFamily="34" charset="-122"/>
+                <a:cs typeface="Aptos Display" pitchFamily="34" charset="-120"/>
+              </a:rPr>
+              <a:t>Wat vandaag het hardst verdedigbaar is, zit niet in hypewoorden maar in infrastructuur en economics.</a:t>
+            </a:r>
+            <a:endParaRPr lang="en-US" sz="1700" dirty="0"/>
+          </a:p>
+        </p:txBody>
+      </p:sp>
+      <p:sp>
+        <p:nvSpPr>
+          <p:cNvPr id="10" name="Shape 7"/>
+          <p:cNvSpPr/>
+          <p:nvPr/>
+        </p:nvSpPr>
+        <p:spPr>
+          <a:xfrm>
+            <a:off x="713232" y="1700784"/>
+            <a:ext cx="3054096" cy="1828800"/>
           </a:xfrm>
           <a:prstGeom prst="roundRect">
             <a:avLst>
-              <a:gd name="adj" fmla="val 1210"/>
+              <a:gd name="adj" fmla="val 3000"/>
             </a:avLst>
           </a:prstGeom>
           <a:solidFill>
@@ -7398,9 +7133,568 @@
           </a:ln>
         </p:spPr>
       </p:sp>
+      <p:sp>
+        <p:nvSpPr>
+          <p:cNvPr id="11" name="Text 8"/>
+          <p:cNvSpPr/>
+          <p:nvPr/>
+        </p:nvSpPr>
+        <p:spPr>
+          <a:xfrm>
+            <a:off x="896112" y="1883664"/>
+            <a:ext cx="2688336" cy="502920"/>
+          </a:xfrm>
+          <a:prstGeom prst="rect">
+            <a:avLst/>
+          </a:prstGeom>
+          <a:noFill/>
+          <a:ln/>
+        </p:spPr>
+        <p:txBody>
+          <a:bodyPr wrap="square" lIns="0" tIns="0" rIns="0" bIns="0" rtlCol="0" anchor="ctr">
+            <a:normAutofit/>
+          </a:bodyPr>
+          <a:lstStyle/>
+          <a:p>
+            <a:pPr indent="0" marL="0">
+              <a:buNone/>
+            </a:pPr>
+            <a:r>
+              <a:rPr lang="en-US" sz="2800" b="1" dirty="0">
+                <a:solidFill>
+                  <a:srgbClr val="E93325"/>
+                </a:solidFill>
+                <a:latin typeface="Aptos Display" pitchFamily="34" charset="0"/>
+                <a:ea typeface="Aptos Display" pitchFamily="34" charset="-122"/>
+                <a:cs typeface="Aptos Display" pitchFamily="34" charset="-120"/>
+              </a:rPr>
+              <a:t>&gt;280x</a:t>
+            </a:r>
+            <a:endParaRPr lang="en-US" sz="2800" dirty="0"/>
+          </a:p>
+        </p:txBody>
+      </p:sp>
+      <p:sp>
+        <p:nvSpPr>
+          <p:cNvPr id="12" name="Text 9"/>
+          <p:cNvSpPr/>
+          <p:nvPr/>
+        </p:nvSpPr>
+        <p:spPr>
+          <a:xfrm>
+            <a:off x="896112" y="2487168"/>
+            <a:ext cx="2688336" cy="237744"/>
+          </a:xfrm>
+          <a:prstGeom prst="rect">
+            <a:avLst/>
+          </a:prstGeom>
+          <a:noFill/>
+          <a:ln/>
+        </p:spPr>
+        <p:txBody>
+          <a:bodyPr wrap="square" lIns="0" tIns="0" rIns="0" bIns="0" rtlCol="0" anchor="ctr">
+            <a:normAutofit/>
+          </a:bodyPr>
+          <a:lstStyle/>
+          <a:p>
+            <a:pPr indent="0" marL="0">
+              <a:buNone/>
+            </a:pPr>
+            <a:r>
+              <a:rPr lang="en-US" sz="1200" b="1" dirty="0">
+                <a:solidFill>
+                  <a:srgbClr val="12192C"/>
+                </a:solidFill>
+                <a:latin typeface="Aptos" pitchFamily="34" charset="0"/>
+                <a:ea typeface="Aptos" pitchFamily="34" charset="-122"/>
+                <a:cs typeface="Aptos" pitchFamily="34" charset="-120"/>
+              </a:rPr>
+              <a:t>kostdaling</a:t>
+            </a:r>
+            <a:endParaRPr lang="en-US" sz="1200" dirty="0"/>
+          </a:p>
+        </p:txBody>
+      </p:sp>
+      <p:sp>
+        <p:nvSpPr>
+          <p:cNvPr id="13" name="Text 10"/>
+          <p:cNvSpPr/>
+          <p:nvPr/>
+        </p:nvSpPr>
+        <p:spPr>
+          <a:xfrm>
+            <a:off x="896112" y="2798064"/>
+            <a:ext cx="2688336" cy="457200"/>
+          </a:xfrm>
+          <a:prstGeom prst="rect">
+            <a:avLst/>
+          </a:prstGeom>
+          <a:noFill/>
+          <a:ln/>
+        </p:spPr>
+        <p:txBody>
+          <a:bodyPr wrap="square" lIns="0" tIns="0" rIns="0" bIns="0" rtlCol="0" anchor="ctr">
+            <a:normAutofit/>
+          </a:bodyPr>
+          <a:lstStyle/>
+          <a:p>
+            <a:pPr indent="0" marL="0">
+              <a:buNone/>
+            </a:pPr>
+            <a:r>
+              <a:rPr lang="en-US" sz="1100" dirty="0">
+                <a:solidFill>
+                  <a:srgbClr val="5B6476"/>
+                </a:solidFill>
+                <a:latin typeface="Aptos" pitchFamily="34" charset="0"/>
+                <a:ea typeface="Aptos" pitchFamily="34" charset="-122"/>
+                <a:cs typeface="Aptos" pitchFamily="34" charset="-120"/>
+              </a:rPr>
+              <a:t>GPT-3.5-kwaliteit, nov 2022 → okt 2024</a:t>
+            </a:r>
+            <a:endParaRPr lang="en-US" sz="1100" dirty="0"/>
+          </a:p>
+        </p:txBody>
+      </p:sp>
+      <p:sp>
+        <p:nvSpPr>
+          <p:cNvPr id="14" name="Shape 11"/>
+          <p:cNvSpPr/>
+          <p:nvPr/>
+        </p:nvSpPr>
+        <p:spPr>
+          <a:xfrm>
+            <a:off x="3968496" y="1700784"/>
+            <a:ext cx="2816352" cy="1828800"/>
+          </a:xfrm>
+          <a:prstGeom prst="roundRect">
+            <a:avLst>
+              <a:gd name="adj" fmla="val 3000"/>
+            </a:avLst>
+          </a:prstGeom>
+          <a:solidFill>
+            <a:srgbClr val="F7F8FB"/>
+          </a:solidFill>
+          <a:ln w="12700">
+            <a:solidFill>
+              <a:srgbClr val="D9DDE6"/>
+            </a:solidFill>
+            <a:prstDash val="solid"/>
+          </a:ln>
+        </p:spPr>
+      </p:sp>
+      <p:sp>
+        <p:nvSpPr>
+          <p:cNvPr id="15" name="Text 12"/>
+          <p:cNvSpPr/>
+          <p:nvPr/>
+        </p:nvSpPr>
+        <p:spPr>
+          <a:xfrm>
+            <a:off x="4151376" y="1883664"/>
+            <a:ext cx="2450592" cy="502920"/>
+          </a:xfrm>
+          <a:prstGeom prst="rect">
+            <a:avLst/>
+          </a:prstGeom>
+          <a:noFill/>
+          <a:ln/>
+        </p:spPr>
+        <p:txBody>
+          <a:bodyPr wrap="square" lIns="0" tIns="0" rIns="0" bIns="0" rtlCol="0" anchor="ctr">
+            <a:normAutofit/>
+          </a:bodyPr>
+          <a:lstStyle/>
+          <a:p>
+            <a:pPr indent="0" marL="0">
+              <a:buNone/>
+            </a:pPr>
+            <a:r>
+              <a:rPr lang="en-US" sz="2800" b="1" dirty="0">
+                <a:solidFill>
+                  <a:srgbClr val="F2AD18"/>
+                </a:solidFill>
+                <a:latin typeface="Aptos Display" pitchFamily="34" charset="0"/>
+                <a:ea typeface="Aptos Display" pitchFamily="34" charset="-122"/>
+                <a:cs typeface="Aptos Display" pitchFamily="34" charset="-120"/>
+              </a:rPr>
+              <a:t>5,0x/jaar</a:t>
+            </a:r>
+            <a:endParaRPr lang="en-US" sz="2800" dirty="0"/>
+          </a:p>
+        </p:txBody>
+      </p:sp>
+      <p:sp>
+        <p:nvSpPr>
+          <p:cNvPr id="16" name="Text 13"/>
+          <p:cNvSpPr/>
+          <p:nvPr/>
+        </p:nvSpPr>
+        <p:spPr>
+          <a:xfrm>
+            <a:off x="4151376" y="2487168"/>
+            <a:ext cx="2450592" cy="237744"/>
+          </a:xfrm>
+          <a:prstGeom prst="rect">
+            <a:avLst/>
+          </a:prstGeom>
+          <a:noFill/>
+          <a:ln/>
+        </p:spPr>
+        <p:txBody>
+          <a:bodyPr wrap="square" lIns="0" tIns="0" rIns="0" bIns="0" rtlCol="0" anchor="ctr">
+            <a:normAutofit/>
+          </a:bodyPr>
+          <a:lstStyle/>
+          <a:p>
+            <a:pPr indent="0" marL="0">
+              <a:buNone/>
+            </a:pPr>
+            <a:r>
+              <a:rPr lang="en-US" sz="1200" b="1" dirty="0">
+                <a:solidFill>
+                  <a:srgbClr val="12192C"/>
+                </a:solidFill>
+                <a:latin typeface="Aptos" pitchFamily="34" charset="0"/>
+                <a:ea typeface="Aptos" pitchFamily="34" charset="-122"/>
+                <a:cs typeface="Aptos" pitchFamily="34" charset="-120"/>
+              </a:rPr>
+              <a:t>training compute</a:t>
+            </a:r>
+            <a:endParaRPr lang="en-US" sz="1200" dirty="0"/>
+          </a:p>
+        </p:txBody>
+      </p:sp>
+      <p:sp>
+        <p:nvSpPr>
+          <p:cNvPr id="17" name="Text 14"/>
+          <p:cNvSpPr/>
+          <p:nvPr/>
+        </p:nvSpPr>
+        <p:spPr>
+          <a:xfrm>
+            <a:off x="4151376" y="2798064"/>
+            <a:ext cx="2450592" cy="457200"/>
+          </a:xfrm>
+          <a:prstGeom prst="rect">
+            <a:avLst/>
+          </a:prstGeom>
+          <a:noFill/>
+          <a:ln/>
+        </p:spPr>
+        <p:txBody>
+          <a:bodyPr wrap="square" lIns="0" tIns="0" rIns="0" bIns="0" rtlCol="0" anchor="ctr">
+            <a:normAutofit/>
+          </a:bodyPr>
+          <a:lstStyle/>
+          <a:p>
+            <a:pPr indent="0" marL="0">
+              <a:buNone/>
+            </a:pPr>
+            <a:r>
+              <a:rPr lang="en-US" sz="1100" dirty="0">
+                <a:solidFill>
+                  <a:srgbClr val="5B6476"/>
+                </a:solidFill>
+                <a:latin typeface="Aptos" pitchFamily="34" charset="0"/>
+                <a:ea typeface="Aptos" pitchFamily="34" charset="-122"/>
+                <a:cs typeface="Aptos" pitchFamily="34" charset="-120"/>
+              </a:rPr>
+              <a:t>Epoch frontier snapshot</a:t>
+            </a:r>
+            <a:endParaRPr lang="en-US" sz="1100" dirty="0"/>
+          </a:p>
+        </p:txBody>
+      </p:sp>
+      <p:sp>
+        <p:nvSpPr>
+          <p:cNvPr id="18" name="Shape 15"/>
+          <p:cNvSpPr/>
+          <p:nvPr/>
+        </p:nvSpPr>
+        <p:spPr>
+          <a:xfrm>
+            <a:off x="6986016" y="1700784"/>
+            <a:ext cx="2688336" cy="1828800"/>
+          </a:xfrm>
+          <a:prstGeom prst="roundRect">
+            <a:avLst>
+              <a:gd name="adj" fmla="val 3000"/>
+            </a:avLst>
+          </a:prstGeom>
+          <a:solidFill>
+            <a:srgbClr val="F7F8FB"/>
+          </a:solidFill>
+          <a:ln w="12700">
+            <a:solidFill>
+              <a:srgbClr val="D9DDE6"/>
+            </a:solidFill>
+            <a:prstDash val="solid"/>
+          </a:ln>
+        </p:spPr>
+      </p:sp>
+      <p:sp>
+        <p:nvSpPr>
+          <p:cNvPr id="19" name="Text 16"/>
+          <p:cNvSpPr/>
+          <p:nvPr/>
+        </p:nvSpPr>
+        <p:spPr>
+          <a:xfrm>
+            <a:off x="7168896" y="1883664"/>
+            <a:ext cx="2322576" cy="502920"/>
+          </a:xfrm>
+          <a:prstGeom prst="rect">
+            <a:avLst/>
+          </a:prstGeom>
+          <a:noFill/>
+          <a:ln/>
+        </p:spPr>
+        <p:txBody>
+          <a:bodyPr wrap="square" lIns="0" tIns="0" rIns="0" bIns="0" rtlCol="0" anchor="ctr">
+            <a:normAutofit/>
+          </a:bodyPr>
+          <a:lstStyle/>
+          <a:p>
+            <a:pPr indent="0" marL="0">
+              <a:buNone/>
+            </a:pPr>
+            <a:r>
+              <a:rPr lang="en-US" sz="2800" b="1" dirty="0">
+                <a:solidFill>
+                  <a:srgbClr val="2563EB"/>
+                </a:solidFill>
+                <a:latin typeface="Aptos Display" pitchFamily="34" charset="0"/>
+                <a:ea typeface="Aptos Display" pitchFamily="34" charset="-122"/>
+                <a:cs typeface="Aptos Display" pitchFamily="34" charset="-120"/>
+              </a:rPr>
+              <a:t>+67,3</a:t>
+            </a:r>
+            <a:endParaRPr lang="en-US" sz="2800" dirty="0"/>
+          </a:p>
+        </p:txBody>
+      </p:sp>
+      <p:sp>
+        <p:nvSpPr>
+          <p:cNvPr id="20" name="Text 17"/>
+          <p:cNvSpPr/>
+          <p:nvPr/>
+        </p:nvSpPr>
+        <p:spPr>
+          <a:xfrm>
+            <a:off x="7168896" y="2487168"/>
+            <a:ext cx="2322576" cy="237744"/>
+          </a:xfrm>
+          <a:prstGeom prst="rect">
+            <a:avLst/>
+          </a:prstGeom>
+          <a:noFill/>
+          <a:ln/>
+        </p:spPr>
+        <p:txBody>
+          <a:bodyPr wrap="square" lIns="0" tIns="0" rIns="0" bIns="0" rtlCol="0" anchor="ctr">
+            <a:normAutofit/>
+          </a:bodyPr>
+          <a:lstStyle/>
+          <a:p>
+            <a:pPr indent="0" marL="0">
+              <a:buNone/>
+            </a:pPr>
+            <a:r>
+              <a:rPr lang="en-US" sz="1200" b="1" dirty="0">
+                <a:solidFill>
+                  <a:srgbClr val="12192C"/>
+                </a:solidFill>
+                <a:latin typeface="Aptos" pitchFamily="34" charset="0"/>
+                <a:ea typeface="Aptos" pitchFamily="34" charset="-122"/>
+                <a:cs typeface="Aptos" pitchFamily="34" charset="-120"/>
+              </a:rPr>
+              <a:t>SWE-bench sprong</a:t>
+            </a:r>
+            <a:endParaRPr lang="en-US" sz="1200" dirty="0"/>
+          </a:p>
+        </p:txBody>
+      </p:sp>
+      <p:sp>
+        <p:nvSpPr>
+          <p:cNvPr id="21" name="Text 18"/>
+          <p:cNvSpPr/>
+          <p:nvPr/>
+        </p:nvSpPr>
+        <p:spPr>
+          <a:xfrm>
+            <a:off x="7168896" y="2798064"/>
+            <a:ext cx="2322576" cy="457200"/>
+          </a:xfrm>
+          <a:prstGeom prst="rect">
+            <a:avLst/>
+          </a:prstGeom>
+          <a:noFill/>
+          <a:ln/>
+        </p:spPr>
+        <p:txBody>
+          <a:bodyPr wrap="square" lIns="0" tIns="0" rIns="0" bIns="0" rtlCol="0" anchor="ctr">
+            <a:normAutofit/>
+          </a:bodyPr>
+          <a:lstStyle/>
+          <a:p>
+            <a:pPr indent="0" marL="0">
+              <a:buNone/>
+            </a:pPr>
+            <a:r>
+              <a:rPr lang="en-US" sz="1100" dirty="0">
+                <a:solidFill>
+                  <a:srgbClr val="5B6476"/>
+                </a:solidFill>
+                <a:latin typeface="Aptos" pitchFamily="34" charset="0"/>
+                <a:ea typeface="Aptos" pitchFamily="34" charset="-122"/>
+                <a:cs typeface="Aptos" pitchFamily="34" charset="-120"/>
+              </a:rPr>
+              <a:t>AI Index benchmark jump</a:t>
+            </a:r>
+            <a:endParaRPr lang="en-US" sz="1100" dirty="0"/>
+          </a:p>
+        </p:txBody>
+      </p:sp>
+      <p:sp>
+        <p:nvSpPr>
+          <p:cNvPr id="22" name="Shape 19"/>
+          <p:cNvSpPr/>
+          <p:nvPr/>
+        </p:nvSpPr>
+        <p:spPr>
+          <a:xfrm>
+            <a:off x="9875520" y="1700784"/>
+            <a:ext cx="1536192" cy="1828800"/>
+          </a:xfrm>
+          <a:prstGeom prst="roundRect">
+            <a:avLst>
+              <a:gd name="adj" fmla="val 3571"/>
+            </a:avLst>
+          </a:prstGeom>
+          <a:solidFill>
+            <a:srgbClr val="F7F8FB"/>
+          </a:solidFill>
+          <a:ln w="12700">
+            <a:solidFill>
+              <a:srgbClr val="D9DDE6"/>
+            </a:solidFill>
+            <a:prstDash val="solid"/>
+          </a:ln>
+        </p:spPr>
+      </p:sp>
+      <p:sp>
+        <p:nvSpPr>
+          <p:cNvPr id="23" name="Text 20"/>
+          <p:cNvSpPr/>
+          <p:nvPr/>
+        </p:nvSpPr>
+        <p:spPr>
+          <a:xfrm>
+            <a:off x="10076688" y="1975104"/>
+            <a:ext cx="914400" cy="146304"/>
+          </a:xfrm>
+          <a:prstGeom prst="rect">
+            <a:avLst/>
+          </a:prstGeom>
+          <a:noFill/>
+          <a:ln/>
+        </p:spPr>
+        <p:txBody>
+          <a:bodyPr wrap="square" lIns="0" tIns="0" rIns="0" bIns="0" rtlCol="0" anchor="ctr">
+            <a:normAutofit/>
+          </a:bodyPr>
+          <a:lstStyle/>
+          <a:p>
+            <a:pPr indent="0" marL="0">
+              <a:buNone/>
+            </a:pPr>
+            <a:r>
+              <a:rPr lang="en-US" sz="1000" b="1" dirty="0">
+                <a:solidFill>
+                  <a:srgbClr val="5B6476"/>
+                </a:solidFill>
+                <a:latin typeface="Aptos" pitchFamily="34" charset="0"/>
+                <a:ea typeface="Aptos" pitchFamily="34" charset="-122"/>
+                <a:cs typeface="Aptos" pitchFamily="34" charset="-120"/>
+              </a:rPr>
+              <a:t>bronlijn</a:t>
+            </a:r>
+            <a:endParaRPr lang="en-US" sz="1000" dirty="0"/>
+          </a:p>
+        </p:txBody>
+      </p:sp>
+      <p:sp>
+        <p:nvSpPr>
+          <p:cNvPr id="24" name="Text 21"/>
+          <p:cNvSpPr/>
+          <p:nvPr/>
+        </p:nvSpPr>
+        <p:spPr>
+          <a:xfrm>
+            <a:off x="10076688" y="2286000"/>
+            <a:ext cx="1005840" cy="365760"/>
+          </a:xfrm>
+          <a:prstGeom prst="rect">
+            <a:avLst/>
+          </a:prstGeom>
+          <a:noFill/>
+          <a:ln/>
+        </p:spPr>
+        <p:txBody>
+          <a:bodyPr wrap="square" lIns="0" tIns="0" rIns="0" bIns="0" rtlCol="0" anchor="ctr">
+            <a:normAutofit/>
+          </a:bodyPr>
+          <a:lstStyle/>
+          <a:p>
+            <a:pPr indent="0" marL="0">
+              <a:buNone/>
+            </a:pPr>
+            <a:r>
+              <a:rPr lang="en-US" sz="1400" b="1" dirty="0">
+                <a:solidFill>
+                  <a:srgbClr val="E93325"/>
+                </a:solidFill>
+                <a:latin typeface="Aptos" pitchFamily="34" charset="0"/>
+                <a:ea typeface="Aptos" pitchFamily="34" charset="-122"/>
+                <a:cs typeface="Aptos" pitchFamily="34" charset="-120"/>
+              </a:rPr>
+              <a:t>Stanford + Epoch</a:t>
+            </a:r>
+            <a:endParaRPr lang="en-US" sz="1400" dirty="0"/>
+          </a:p>
+        </p:txBody>
+      </p:sp>
+      <p:sp>
+        <p:nvSpPr>
+          <p:cNvPr id="25" name="Shape 22"/>
+          <p:cNvSpPr/>
+          <p:nvPr/>
+        </p:nvSpPr>
+        <p:spPr>
+          <a:xfrm>
+            <a:off x="713232" y="3730752"/>
+            <a:ext cx="4663440" cy="1792224"/>
+          </a:xfrm>
+          <a:prstGeom prst="roundRect">
+            <a:avLst>
+              <a:gd name="adj" fmla="val 3061"/>
+            </a:avLst>
+          </a:prstGeom>
+          <a:solidFill>
+            <a:srgbClr val="F7F8FB"/>
+          </a:solidFill>
+          <a:ln w="12700">
+            <a:solidFill>
+              <a:srgbClr val="D9DDE6"/>
+            </a:solidFill>
+            <a:prstDash val="solid"/>
+          </a:ln>
+        </p:spPr>
+      </p:sp>
       <p:pic>
         <p:nvPicPr>
-          <p:cNvPr id="10" name="Image 1" descr="/home/ff/Documents/BoostMeUp/MoltBook_Sessie/assets/ai_trends.png">    </p:cNvPr>
+          <p:cNvPr id="26" name="Image 1" descr="/home/ff/Documents/BoostMeUp/MoltBook_Sessie/assets/ai_trends.png">    </p:cNvPr>
           <p:cNvPicPr>
             <a:picLocks noChangeAspect="1"/>
           </p:cNvPicPr>
@@ -7414,8 +7708,8 @@
         </p:blipFill>
         <p:spPr>
           <a:xfrm>
-            <a:off x="822960" y="1335024"/>
-            <a:ext cx="7324344" cy="4315968"/>
+            <a:off x="822960" y="3840480"/>
+            <a:ext cx="4443984" cy="1572768"/>
           </a:xfrm>
           <a:prstGeom prst="rect">
             <a:avLst/>
@@ -7424,18 +7718,18 @@
       </p:pic>
       <p:sp>
         <p:nvSpPr>
-          <p:cNvPr id="11" name="Shape 7"/>
-          <p:cNvSpPr/>
-          <p:nvPr/>
-        </p:nvSpPr>
-        <p:spPr>
-          <a:xfrm>
-            <a:off x="8449056" y="1225296"/>
-            <a:ext cx="3191256" cy="4535424"/>
+          <p:cNvPr id="27" name="Shape 23"/>
+          <p:cNvSpPr/>
+          <p:nvPr/>
+        </p:nvSpPr>
+        <p:spPr>
+          <a:xfrm>
+            <a:off x="5577840" y="3730752"/>
+            <a:ext cx="6062472" cy="1792224"/>
           </a:xfrm>
           <a:prstGeom prst="roundRect">
             <a:avLst>
-              <a:gd name="adj" fmla="val 1719"/>
+              <a:gd name="adj" fmla="val 3061"/>
             </a:avLst>
           </a:prstGeom>
           <a:solidFill>
@@ -7451,159 +7745,14 @@
       </p:sp>
       <p:sp>
         <p:nvSpPr>
-          <p:cNvPr id="12" name="Shape 8"/>
-          <p:cNvSpPr/>
-          <p:nvPr/>
-        </p:nvSpPr>
-        <p:spPr>
-          <a:xfrm>
-            <a:off x="8668512" y="1499616"/>
-            <a:ext cx="1426464" cy="329184"/>
-          </a:xfrm>
-          <a:prstGeom prst="roundRect">
-            <a:avLst>
-              <a:gd name="adj" fmla="val 22222"/>
-            </a:avLst>
-          </a:prstGeom>
-          <a:solidFill>
-            <a:srgbClr val="E93325"/>
-          </a:solidFill>
-          <a:ln w="12700">
-            <a:solidFill>
-              <a:srgbClr val="E93325">
-                <a:alpha val="0"/>
-              </a:srgbClr>
-            </a:solidFill>
-            <a:prstDash val="solid"/>
-          </a:ln>
-        </p:spPr>
-      </p:sp>
-      <p:sp>
-        <p:nvSpPr>
-          <p:cNvPr id="13" name="Text 9"/>
-          <p:cNvSpPr/>
-          <p:nvPr/>
-        </p:nvSpPr>
-        <p:spPr>
-          <a:xfrm>
-            <a:off x="8814816" y="1572768"/>
-            <a:ext cx="1133856" cy="164592"/>
-          </a:xfrm>
-          <a:prstGeom prst="rect">
-            <a:avLst/>
-          </a:prstGeom>
-          <a:noFill/>
-          <a:ln/>
-        </p:spPr>
-        <p:txBody>
-          <a:bodyPr wrap="square" lIns="0" tIns="0" rIns="0" bIns="0" rtlCol="0" anchor="ctr">
-            <a:normAutofit/>
-          </a:bodyPr>
-          <a:lstStyle/>
-          <a:p>
-            <a:pPr indent="0" marL="0">
-              <a:buNone/>
-            </a:pPr>
-            <a:r>
-              <a:rPr lang="en-US" sz="900" b="1" dirty="0">
-                <a:solidFill>
-                  <a:srgbClr val="FFFFFF"/>
-                </a:solidFill>
-                <a:latin typeface="Aptos" pitchFamily="34" charset="0"/>
-                <a:ea typeface="Aptos" pitchFamily="34" charset="-122"/>
-                <a:cs typeface="Aptos" pitchFamily="34" charset="-120"/>
-              </a:rPr>
-              <a:t>wat dit wél toont</a:t>
-            </a:r>
-            <a:endParaRPr lang="en-US" sz="900" dirty="0"/>
-          </a:p>
-        </p:txBody>
-      </p:sp>
-      <p:sp>
-        <p:nvSpPr>
-          <p:cNvPr id="14" name="Text 10"/>
-          <p:cNvSpPr/>
-          <p:nvPr/>
-        </p:nvSpPr>
-        <p:spPr>
-          <a:xfrm>
-            <a:off x="8668512" y="1938528"/>
-            <a:ext cx="2560320" cy="1170432"/>
-          </a:xfrm>
-          <a:prstGeom prst="rect">
-            <a:avLst/>
-          </a:prstGeom>
-          <a:noFill/>
-          <a:ln/>
-        </p:spPr>
-        <p:txBody>
-          <a:bodyPr wrap="square" lIns="0" tIns="0" rIns="0" bIns="0" rtlCol="0" anchor="ctr">
-            <a:normAutofit/>
-          </a:bodyPr>
-          <a:lstStyle/>
-          <a:p>
-            <a:pPr indent="0" marL="0">
-              <a:buNone/>
-            </a:pPr>
-            <a:r>
-              <a:rPr lang="en-US" sz="1600" b="1" dirty="0">
-                <a:solidFill>
-                  <a:srgbClr val="FFFFFF"/>
-                </a:solidFill>
-                <a:latin typeface="Aptos" pitchFamily="34" charset="0"/>
-                <a:ea typeface="Aptos" pitchFamily="34" charset="-122"/>
-                <a:cs typeface="Aptos" pitchFamily="34" charset="-120"/>
-              </a:rPr>
-              <a:t>grote benchmarksprongen</a:t>
-            </a:r>
-            <a:endParaRPr lang="en-US" sz="1600" dirty="0"/>
-          </a:p>
-          <a:p>
-            <a:pPr indent="0" marL="0">
-              <a:buNone/>
-            </a:pPr>
-            <a:r>
-              <a:rPr lang="en-US" sz="1600" b="1" dirty="0">
-                <a:solidFill>
-                  <a:srgbClr val="FFFFFF"/>
-                </a:solidFill>
-                <a:latin typeface="Aptos" pitchFamily="34" charset="0"/>
-                <a:ea typeface="Aptos" pitchFamily="34" charset="-122"/>
-                <a:cs typeface="Aptos" pitchFamily="34" charset="-120"/>
-              </a:rPr>
-              <a:t>&gt;280x kostdaling</a:t>
-            </a:r>
-            <a:endParaRPr lang="en-US" sz="1600" dirty="0"/>
-          </a:p>
-          <a:p>
-            <a:pPr indent="0" marL="0">
-              <a:buNone/>
-            </a:pPr>
-            <a:r>
-              <a:rPr lang="en-US" sz="1600" b="1" dirty="0">
-                <a:solidFill>
-                  <a:srgbClr val="FFFFFF"/>
-                </a:solidFill>
-                <a:latin typeface="Aptos" pitchFamily="34" charset="0"/>
-                <a:ea typeface="Aptos" pitchFamily="34" charset="-122"/>
-                <a:cs typeface="Aptos" pitchFamily="34" charset="-120"/>
-              </a:rPr>
-              <a:t>sterke compute- en efficiencygroei</a:t>
-            </a:r>
-            <a:endParaRPr lang="en-US" sz="1600" dirty="0"/>
-          </a:p>
-        </p:txBody>
-      </p:sp>
-      <p:sp>
-        <p:nvSpPr>
-          <p:cNvPr id="15" name="Shape 11"/>
-          <p:cNvSpPr/>
-          <p:nvPr/>
-        </p:nvSpPr>
-        <p:spPr>
-          <a:xfrm>
-            <a:off x="8668512" y="3456432"/>
-            <a:ext cx="1517904" cy="329184"/>
+          <p:cNvPr id="28" name="Shape 24"/>
+          <p:cNvSpPr/>
+          <p:nvPr/>
+        </p:nvSpPr>
+        <p:spPr>
+          <a:xfrm>
+            <a:off x="5797296" y="3968496"/>
+            <a:ext cx="1591056" cy="329184"/>
           </a:xfrm>
           <a:prstGeom prst="roundRect">
             <a:avLst>
@@ -7625,14 +7774,14 @@
       </p:sp>
       <p:sp>
         <p:nvSpPr>
-          <p:cNvPr id="16" name="Text 12"/>
-          <p:cNvSpPr/>
-          <p:nvPr/>
-        </p:nvSpPr>
-        <p:spPr>
-          <a:xfrm>
-            <a:off x="8814816" y="3529584"/>
-            <a:ext cx="1225296" cy="164592"/>
+          <p:cNvPr id="29" name="Text 25"/>
+          <p:cNvSpPr/>
+          <p:nvPr/>
+        </p:nvSpPr>
+        <p:spPr>
+          <a:xfrm>
+            <a:off x="5943600" y="4041648"/>
+            <a:ext cx="1298448" cy="164592"/>
           </a:xfrm>
           <a:prstGeom prst="rect">
             <a:avLst/>
@@ -7658,7 +7807,7 @@
                 <a:ea typeface="Aptos" pitchFamily="34" charset="-122"/>
                 <a:cs typeface="Aptos" pitchFamily="34" charset="-120"/>
               </a:rPr>
-              <a:t>wat dit níét zegt</a:t>
+              <a:t>voorzichtigheid blijft</a:t>
             </a:r>
             <a:endParaRPr lang="en-US" sz="900" dirty="0"/>
           </a:p>
@@ -7666,71 +7815,71 @@
       </p:sp>
       <p:sp>
         <p:nvSpPr>
-          <p:cNvPr id="17" name="Text 13"/>
-          <p:cNvSpPr/>
-          <p:nvPr/>
-        </p:nvSpPr>
-        <p:spPr>
-          <a:xfrm>
-            <a:off x="8668512" y="3895344"/>
-            <a:ext cx="2578608" cy="896112"/>
-          </a:xfrm>
-          <a:prstGeom prst="rect">
-            <a:avLst/>
-          </a:prstGeom>
-          <a:noFill/>
-          <a:ln/>
-        </p:spPr>
-        <p:txBody>
-          <a:bodyPr wrap="square" lIns="0" tIns="0" rIns="0" bIns="0" rtlCol="0" anchor="ctr">
-            <a:normAutofit/>
-          </a:bodyPr>
-          <a:lstStyle/>
-          <a:p>
-            <a:pPr indent="0" marL="0">
-              <a:buNone/>
-            </a:pPr>
-            <a:r>
-              <a:rPr lang="en-US" sz="1400" dirty="0">
+          <p:cNvPr id="30" name="Text 26"/>
+          <p:cNvSpPr/>
+          <p:nvPr/>
+        </p:nvSpPr>
+        <p:spPr>
+          <a:xfrm>
+            <a:off x="5797296" y="4407408"/>
+            <a:ext cx="5376672" cy="676656"/>
+          </a:xfrm>
+          <a:prstGeom prst="rect">
+            <a:avLst/>
+          </a:prstGeom>
+          <a:noFill/>
+          <a:ln/>
+        </p:spPr>
+        <p:txBody>
+          <a:bodyPr wrap="square" lIns="0" tIns="0" rIns="0" bIns="0" rtlCol="0" anchor="ctr">
+            <a:normAutofit/>
+          </a:bodyPr>
+          <a:lstStyle/>
+          <a:p>
+            <a:pPr indent="0" marL="0">
+              <a:buNone/>
+            </a:pPr>
+            <a:r>
+              <a:rPr lang="en-US" sz="1700" b="1" dirty="0">
                 <a:solidFill>
                   <a:srgbClr val="FFFFFF"/>
                 </a:solidFill>
-                <a:latin typeface="Aptos" pitchFamily="34" charset="0"/>
-                <a:ea typeface="Aptos" pitchFamily="34" charset="-122"/>
-                <a:cs typeface="Aptos" pitchFamily="34" charset="-120"/>
-              </a:rPr>
-              <a:t>niet elke capability-curve blijft netjes exponentieel</a:t>
-            </a:r>
-            <a:endParaRPr lang="en-US" sz="1400" dirty="0"/>
-          </a:p>
-          <a:p>
-            <a:pPr indent="0" marL="0">
-              <a:buNone/>
-            </a:pPr>
-            <a:r>
-              <a:rPr lang="en-US" sz="1400" dirty="0">
+                <a:latin typeface="Aptos Display" pitchFamily="34" charset="0"/>
+                <a:ea typeface="Aptos Display" pitchFamily="34" charset="-122"/>
+                <a:cs typeface="Aptos Display" pitchFamily="34" charset="-120"/>
+              </a:rPr>
+              <a:t>Niet elke capability-curve blijft netjes exponentieel.</a:t>
+            </a:r>
+            <a:endParaRPr lang="en-US" sz="1700" dirty="0"/>
+          </a:p>
+          <a:p>
+            <a:pPr indent="0" marL="0">
+              <a:buNone/>
+            </a:pPr>
+            <a:r>
+              <a:rPr lang="en-US" sz="1700" b="1" dirty="0">
                 <a:solidFill>
                   <a:srgbClr val="FFFFFF"/>
                 </a:solidFill>
-                <a:latin typeface="Aptos" pitchFamily="34" charset="0"/>
-                <a:ea typeface="Aptos" pitchFamily="34" charset="-122"/>
-                <a:cs typeface="Aptos" pitchFamily="34" charset="-120"/>
-              </a:rPr>
-              <a:t>bounded benchmarks kunnen satureren</a:t>
-            </a:r>
-            <a:endParaRPr lang="en-US" sz="1400" dirty="0"/>
-          </a:p>
-        </p:txBody>
-      </p:sp>
-      <p:sp>
-        <p:nvSpPr>
-          <p:cNvPr id="18" name="Shape 14"/>
-          <p:cNvSpPr/>
-          <p:nvPr/>
-        </p:nvSpPr>
-        <p:spPr>
-          <a:xfrm>
-            <a:off x="713232" y="5504688"/>
+                <a:latin typeface="Aptos Display" pitchFamily="34" charset="0"/>
+                <a:ea typeface="Aptos Display" pitchFamily="34" charset="-122"/>
+                <a:cs typeface="Aptos Display" pitchFamily="34" charset="-120"/>
+              </a:rPr>
+              <a:t>Bounded benchmarks kunnen satureren, dus lees capability minder hard dan kosten, compute en efficiency.</a:t>
+            </a:r>
+            <a:endParaRPr lang="en-US" sz="1700" dirty="0"/>
+          </a:p>
+        </p:txBody>
+      </p:sp>
+      <p:sp>
+        <p:nvSpPr>
+          <p:cNvPr id="31" name="Shape 27"/>
+          <p:cNvSpPr/>
+          <p:nvPr/>
+        </p:nvSpPr>
+        <p:spPr>
+          <a:xfrm>
+            <a:off x="713232" y="5596128"/>
             <a:ext cx="10927080" cy="640080"/>
           </a:xfrm>
           <a:prstGeom prst="roundRect">
@@ -7751,13 +7900,13 @@
       </p:sp>
       <p:sp>
         <p:nvSpPr>
-          <p:cNvPr id="19" name="Text 15"/>
-          <p:cNvSpPr/>
-          <p:nvPr/>
-        </p:nvSpPr>
-        <p:spPr>
-          <a:xfrm>
-            <a:off x="932688" y="5669280"/>
+          <p:cNvPr id="32" name="Text 28"/>
+          <p:cNvSpPr/>
+          <p:nvPr/>
+        </p:nvSpPr>
+        <p:spPr>
+          <a:xfrm>
+            <a:off x="932688" y="5760720"/>
             <a:ext cx="10469880" cy="201168"/>
           </a:xfrm>
           <a:prstGeom prst="rect">
@@ -7784,7 +7933,7 @@
                 <a:ea typeface="Aptos" pitchFamily="34" charset="-122"/>
                 <a:cs typeface="Aptos" pitchFamily="34" charset="-120"/>
               </a:rPr>
-              <a:t>Takeaway: kijk harder naar kosten, compute en efficiency dan naar één spectaculaire scorelijn.</a:t>
+              <a:t>Takeaway: onthoud vooral kostdaling, compute en efficiency. Niet één spectaculaire scorelijn.</a:t>
             </a:r>
             <a:endParaRPr lang="en-US" sz="1200" dirty="0"/>
           </a:p>
@@ -8999,25 +9148,25 @@
         <p:spPr>
           <a:xfrm>
             <a:off x="713232" y="1188720"/>
-            <a:ext cx="5669280" cy="493776"/>
-          </a:xfrm>
-          <a:prstGeom prst="rect">
-            <a:avLst/>
-          </a:prstGeom>
-          <a:noFill/>
-          <a:ln/>
-        </p:spPr>
-        <p:txBody>
-          <a:bodyPr wrap="square" lIns="0" tIns="0" rIns="0" bIns="0" rtlCol="0" anchor="ctr">
-            <a:normAutofit/>
-          </a:bodyPr>
-          <a:lstStyle/>
-          <a:p>
-            <a:pPr indent="0" marL="0">
-              <a:buNone/>
-            </a:pPr>
-            <a:r>
-              <a:rPr lang="en-US" sz="2000" b="1" dirty="0">
+            <a:ext cx="6400800" cy="493776"/>
+          </a:xfrm>
+          <a:prstGeom prst="rect">
+            <a:avLst/>
+          </a:prstGeom>
+          <a:noFill/>
+          <a:ln/>
+        </p:spPr>
+        <p:txBody>
+          <a:bodyPr wrap="square" lIns="0" tIns="0" rIns="0" bIns="0" rtlCol="0" anchor="ctr">
+            <a:normAutofit/>
+          </a:bodyPr>
+          <a:lstStyle/>
+          <a:p>
+            <a:pPr indent="0" marL="0">
+              <a:buNone/>
+            </a:pPr>
+            <a:r>
+              <a:rPr lang="en-US" sz="2200" b="1" dirty="0">
                 <a:solidFill>
                   <a:srgbClr val="12192C"/>
                 </a:solidFill>
@@ -9025,16 +9174,16 @@
                 <a:ea typeface="Aptos Display" pitchFamily="34" charset="-122"/>
                 <a:cs typeface="Aptos Display" pitchFamily="34" charset="-120"/>
               </a:rPr>
-              <a:t>Niet vragen: welk jaar belooft dit model?</a:t>
-            </a:r>
-            <a:endParaRPr lang="en-US" sz="2000" dirty="0"/>
-          </a:p>
-          <a:p>
-            <a:pPr indent="0" marL="0">
-              <a:buNone/>
-            </a:pPr>
-            <a:r>
-              <a:rPr lang="en-US" sz="2000" b="1" dirty="0">
+              <a:t>Niet onthouden: één jaartal.</a:t>
+            </a:r>
+            <a:endParaRPr lang="en-US" sz="2200" dirty="0"/>
+          </a:p>
+          <a:p>
+            <a:pPr indent="0" marL="0">
+              <a:buNone/>
+            </a:pPr>
+            <a:r>
+              <a:rPr lang="en-US" sz="2200" b="1" dirty="0">
                 <a:solidFill>
                   <a:srgbClr val="12192C"/>
                 </a:solidFill>
@@ -9042,9 +9191,9 @@
                 <a:ea typeface="Aptos Display" pitchFamily="34" charset="-122"/>
                 <a:cs typeface="Aptos Display" pitchFamily="34" charset="-120"/>
               </a:rPr>
-              <a:t>Wel vragen: welke aannames duwen de uitkomst echt?</a:t>
-            </a:r>
-            <a:endParaRPr lang="en-US" sz="2000" dirty="0"/>
+              <a:t>Wel onthouden: welke bottlenecks de uitkomst sturen.</a:t>
+            </a:r>
+            <a:endParaRPr lang="en-US" sz="2200" dirty="0"/>
           </a:p>
         </p:txBody>
       </p:sp>
@@ -9056,571 +9205,12 @@
         </p:nvSpPr>
         <p:spPr>
           <a:xfrm>
-            <a:off x="713232" y="1920240"/>
-            <a:ext cx="3063240" cy="1828800"/>
+            <a:off x="713232" y="1901952"/>
+            <a:ext cx="10927080" cy="1956816"/>
           </a:xfrm>
           <a:prstGeom prst="roundRect">
             <a:avLst>
-              <a:gd name="adj" fmla="val 3000"/>
-            </a:avLst>
-          </a:prstGeom>
-          <a:solidFill>
-            <a:srgbClr val="F7F8FB"/>
-          </a:solidFill>
-          <a:ln w="12700">
-            <a:solidFill>
-              <a:srgbClr val="D9DDE6"/>
-            </a:solidFill>
-            <a:prstDash val="solid"/>
-          </a:ln>
-        </p:spPr>
-      </p:sp>
-      <p:sp>
-        <p:nvSpPr>
-          <p:cNvPr id="11" name="Text 8"/>
-          <p:cNvSpPr/>
-          <p:nvPr/>
-        </p:nvSpPr>
-        <p:spPr>
-          <a:xfrm>
-            <a:off x="896112" y="2103120"/>
-            <a:ext cx="2697480" cy="502920"/>
-          </a:xfrm>
-          <a:prstGeom prst="rect">
-            <a:avLst/>
-          </a:prstGeom>
-          <a:noFill/>
-          <a:ln/>
-        </p:spPr>
-        <p:txBody>
-          <a:bodyPr wrap="square" lIns="0" tIns="0" rIns="0" bIns="0" rtlCol="0" anchor="ctr">
-            <a:normAutofit/>
-          </a:bodyPr>
-          <a:lstStyle/>
-          <a:p>
-            <a:pPr indent="0" marL="0">
-              <a:buNone/>
-            </a:pPr>
-            <a:r>
-              <a:rPr lang="en-US" sz="2800" b="1" dirty="0">
-                <a:solidFill>
-                  <a:srgbClr val="E93325"/>
-                </a:solidFill>
-                <a:latin typeface="Aptos Display" pitchFamily="34" charset="0"/>
-                <a:ea typeface="Aptos Display" pitchFamily="34" charset="-122"/>
-                <a:cs typeface="Aptos Display" pitchFamily="34" charset="-120"/>
-              </a:rPr>
-              <a:t>28,1%</a:t>
-            </a:r>
-            <a:endParaRPr lang="en-US" sz="2800" dirty="0"/>
-          </a:p>
-        </p:txBody>
-      </p:sp>
-      <p:sp>
-        <p:nvSpPr>
-          <p:cNvPr id="12" name="Text 9"/>
-          <p:cNvSpPr/>
-          <p:nvPr/>
-        </p:nvSpPr>
-        <p:spPr>
-          <a:xfrm>
-            <a:off x="896112" y="2706624"/>
-            <a:ext cx="2697480" cy="237744"/>
-          </a:xfrm>
-          <a:prstGeom prst="rect">
-            <a:avLst/>
-          </a:prstGeom>
-          <a:noFill/>
-          <a:ln/>
-        </p:spPr>
-        <p:txBody>
-          <a:bodyPr wrap="square" lIns="0" tIns="0" rIns="0" bIns="0" rtlCol="0" anchor="ctr">
-            <a:normAutofit/>
-          </a:bodyPr>
-          <a:lstStyle/>
-          <a:p>
-            <a:pPr indent="0" marL="0">
-              <a:buNone/>
-            </a:pPr>
-            <a:r>
-              <a:rPr lang="en-US" sz="1200" b="1" dirty="0">
-                <a:solidFill>
-                  <a:srgbClr val="12192C"/>
-                </a:solidFill>
-                <a:latin typeface="Aptos" pitchFamily="34" charset="0"/>
-                <a:ea typeface="Aptos" pitchFamily="34" charset="-122"/>
-                <a:cs typeface="Aptos" pitchFamily="34" charset="-120"/>
-              </a:rPr>
-              <a:t>basisscenario tegen 2040</a:t>
-            </a:r>
-            <a:endParaRPr lang="en-US" sz="1200" dirty="0"/>
-          </a:p>
-        </p:txBody>
-      </p:sp>
-      <p:sp>
-        <p:nvSpPr>
-          <p:cNvPr id="13" name="Text 10"/>
-          <p:cNvSpPr/>
-          <p:nvPr/>
-        </p:nvSpPr>
-        <p:spPr>
-          <a:xfrm>
-            <a:off x="896112" y="3017520"/>
-            <a:ext cx="2697480" cy="457200"/>
-          </a:xfrm>
-          <a:prstGeom prst="rect">
-            <a:avLst/>
-          </a:prstGeom>
-          <a:noFill/>
-          <a:ln/>
-        </p:spPr>
-        <p:txBody>
-          <a:bodyPr wrap="square" lIns="0" tIns="0" rIns="0" bIns="0" rtlCol="0" anchor="ctr">
-            <a:normAutofit/>
-          </a:bodyPr>
-          <a:lstStyle/>
-          <a:p>
-            <a:pPr indent="0" marL="0">
-              <a:buNone/>
-            </a:pPr>
-            <a:r>
-              <a:rPr lang="en-US" sz="1100" dirty="0">
-                <a:solidFill>
-                  <a:srgbClr val="5B6476"/>
-                </a:solidFill>
-                <a:latin typeface="Aptos" pitchFamily="34" charset="0"/>
-                <a:ea typeface="Aptos" pitchFamily="34" charset="-122"/>
-                <a:cs typeface="Aptos" pitchFamily="34" charset="-120"/>
-              </a:rPr>
-              <a:t>kans op crossing</a:t>
-            </a:r>
-            <a:endParaRPr lang="en-US" sz="1100" dirty="0"/>
-          </a:p>
-        </p:txBody>
-      </p:sp>
-      <p:sp>
-        <p:nvSpPr>
-          <p:cNvPr id="14" name="Shape 11"/>
-          <p:cNvSpPr/>
-          <p:nvPr/>
-        </p:nvSpPr>
-        <p:spPr>
-          <a:xfrm>
-            <a:off x="3968496" y="1920240"/>
-            <a:ext cx="2560320" cy="1828800"/>
-          </a:xfrm>
-          <a:prstGeom prst="roundRect">
-            <a:avLst>
-              <a:gd name="adj" fmla="val 3000"/>
-            </a:avLst>
-          </a:prstGeom>
-          <a:solidFill>
-            <a:srgbClr val="F7F8FB"/>
-          </a:solidFill>
-          <a:ln w="12700">
-            <a:solidFill>
-              <a:srgbClr val="D9DDE6"/>
-            </a:solidFill>
-            <a:prstDash val="solid"/>
-          </a:ln>
-        </p:spPr>
-      </p:sp>
-      <p:sp>
-        <p:nvSpPr>
-          <p:cNvPr id="15" name="Text 12"/>
-          <p:cNvSpPr/>
-          <p:nvPr/>
-        </p:nvSpPr>
-        <p:spPr>
-          <a:xfrm>
-            <a:off x="4151376" y="2103120"/>
-            <a:ext cx="2194560" cy="502920"/>
-          </a:xfrm>
-          <a:prstGeom prst="rect">
-            <a:avLst/>
-          </a:prstGeom>
-          <a:noFill/>
-          <a:ln/>
-        </p:spPr>
-        <p:txBody>
-          <a:bodyPr wrap="square" lIns="0" tIns="0" rIns="0" bIns="0" rtlCol="0" anchor="ctr">
-            <a:normAutofit/>
-          </a:bodyPr>
-          <a:lstStyle/>
-          <a:p>
-            <a:pPr indent="0" marL="0">
-              <a:buNone/>
-            </a:pPr>
-            <a:r>
-              <a:rPr lang="en-US" sz="2800" b="1" dirty="0">
-                <a:solidFill>
-                  <a:srgbClr val="F2AD18"/>
-                </a:solidFill>
-                <a:latin typeface="Aptos Display" pitchFamily="34" charset="0"/>
-                <a:ea typeface="Aptos Display" pitchFamily="34" charset="-122"/>
-                <a:cs typeface="Aptos Display" pitchFamily="34" charset="-120"/>
-              </a:rPr>
-              <a:t>2038</a:t>
-            </a:r>
-            <a:endParaRPr lang="en-US" sz="2800" dirty="0"/>
-          </a:p>
-        </p:txBody>
-      </p:sp>
-      <p:sp>
-        <p:nvSpPr>
-          <p:cNvPr id="16" name="Text 13"/>
-          <p:cNvSpPr/>
-          <p:nvPr/>
-        </p:nvSpPr>
-        <p:spPr>
-          <a:xfrm>
-            <a:off x="4151376" y="2706624"/>
-            <a:ext cx="2194560" cy="237744"/>
-          </a:xfrm>
-          <a:prstGeom prst="rect">
-            <a:avLst/>
-          </a:prstGeom>
-          <a:noFill/>
-          <a:ln/>
-        </p:spPr>
-        <p:txBody>
-          <a:bodyPr wrap="square" lIns="0" tIns="0" rIns="0" bIns="0" rtlCol="0" anchor="ctr">
-            <a:normAutofit/>
-          </a:bodyPr>
-          <a:lstStyle/>
-          <a:p>
-            <a:pPr indent="0" marL="0">
-              <a:buNone/>
-            </a:pPr>
-            <a:r>
-              <a:rPr lang="en-US" sz="1200" b="1" dirty="0">
-                <a:solidFill>
-                  <a:srgbClr val="12192C"/>
-                </a:solidFill>
-                <a:latin typeface="Aptos" pitchFamily="34" charset="0"/>
-                <a:ea typeface="Aptos" pitchFamily="34" charset="-122"/>
-                <a:cs typeface="Aptos" pitchFamily="34" charset="-120"/>
-              </a:rPr>
-              <a:t>mediaan in basisscenario</a:t>
-            </a:r>
-            <a:endParaRPr lang="en-US" sz="1200" dirty="0"/>
-          </a:p>
-        </p:txBody>
-      </p:sp>
-      <p:sp>
-        <p:nvSpPr>
-          <p:cNvPr id="17" name="Text 14"/>
-          <p:cNvSpPr/>
-          <p:nvPr/>
-        </p:nvSpPr>
-        <p:spPr>
-          <a:xfrm>
-            <a:off x="4151376" y="3017520"/>
-            <a:ext cx="2194560" cy="457200"/>
-          </a:xfrm>
-          <a:prstGeom prst="rect">
-            <a:avLst/>
-          </a:prstGeom>
-          <a:noFill/>
-          <a:ln/>
-        </p:spPr>
-        <p:txBody>
-          <a:bodyPr wrap="square" lIns="0" tIns="0" rIns="0" bIns="0" rtlCol="0" anchor="ctr">
-            <a:normAutofit/>
-          </a:bodyPr>
-          <a:lstStyle/>
-          <a:p>
-            <a:pPr indent="0" marL="0">
-              <a:buNone/>
-            </a:pPr>
-            <a:r>
-              <a:rPr lang="en-US" sz="1100" dirty="0">
-                <a:solidFill>
-                  <a:srgbClr val="5B6476"/>
-                </a:solidFill>
-                <a:latin typeface="Aptos" pitchFamily="34" charset="0"/>
-                <a:ea typeface="Aptos" pitchFamily="34" charset="-122"/>
-                <a:cs typeface="Aptos" pitchFamily="34" charset="-120"/>
-              </a:rPr>
-              <a:t>geen datum-belofte</a:t>
-            </a:r>
-            <a:endParaRPr lang="en-US" sz="1100" dirty="0"/>
-          </a:p>
-        </p:txBody>
-      </p:sp>
-      <p:sp>
-        <p:nvSpPr>
-          <p:cNvPr id="18" name="Shape 15"/>
-          <p:cNvSpPr/>
-          <p:nvPr/>
-        </p:nvSpPr>
-        <p:spPr>
-          <a:xfrm>
-            <a:off x="6729984" y="1920240"/>
-            <a:ext cx="2962656" cy="1828800"/>
-          </a:xfrm>
-          <a:prstGeom prst="roundRect">
-            <a:avLst>
-              <a:gd name="adj" fmla="val 3000"/>
-            </a:avLst>
-          </a:prstGeom>
-          <a:solidFill>
-            <a:srgbClr val="F7F8FB"/>
-          </a:solidFill>
-          <a:ln w="12700">
-            <a:solidFill>
-              <a:srgbClr val="D9DDE6"/>
-            </a:solidFill>
-            <a:prstDash val="solid"/>
-          </a:ln>
-        </p:spPr>
-      </p:sp>
-      <p:sp>
-        <p:nvSpPr>
-          <p:cNvPr id="19" name="Text 16"/>
-          <p:cNvSpPr/>
-          <p:nvPr/>
-        </p:nvSpPr>
-        <p:spPr>
-          <a:xfrm>
-            <a:off x="6912864" y="2103120"/>
-            <a:ext cx="2596896" cy="502920"/>
-          </a:xfrm>
-          <a:prstGeom prst="rect">
-            <a:avLst/>
-          </a:prstGeom>
-          <a:noFill/>
-          <a:ln/>
-        </p:spPr>
-        <p:txBody>
-          <a:bodyPr wrap="square" lIns="0" tIns="0" rIns="0" bIns="0" rtlCol="0" anchor="ctr">
-            <a:normAutofit/>
-          </a:bodyPr>
-          <a:lstStyle/>
-          <a:p>
-            <a:pPr indent="0" marL="0">
-              <a:buNone/>
-            </a:pPr>
-            <a:r>
-              <a:rPr lang="en-US" sz="2800" b="1" dirty="0">
-                <a:solidFill>
-                  <a:srgbClr val="0F766E"/>
-                </a:solidFill>
-                <a:latin typeface="Aptos Display" pitchFamily="34" charset="0"/>
-                <a:ea typeface="Aptos Display" pitchFamily="34" charset="-122"/>
-                <a:cs typeface="Aptos Display" pitchFamily="34" charset="-120"/>
-              </a:rPr>
-              <a:t>71,9%</a:t>
-            </a:r>
-            <a:endParaRPr lang="en-US" sz="2800" dirty="0"/>
-          </a:p>
-        </p:txBody>
-      </p:sp>
-      <p:sp>
-        <p:nvSpPr>
-          <p:cNvPr id="20" name="Text 17"/>
-          <p:cNvSpPr/>
-          <p:nvPr/>
-        </p:nvSpPr>
-        <p:spPr>
-          <a:xfrm>
-            <a:off x="6912864" y="2706624"/>
-            <a:ext cx="2596896" cy="237744"/>
-          </a:xfrm>
-          <a:prstGeom prst="rect">
-            <a:avLst/>
-          </a:prstGeom>
-          <a:noFill/>
-          <a:ln/>
-        </p:spPr>
-        <p:txBody>
-          <a:bodyPr wrap="square" lIns="0" tIns="0" rIns="0" bIns="0" rtlCol="0" anchor="ctr">
-            <a:normAutofit/>
-          </a:bodyPr>
-          <a:lstStyle/>
-          <a:p>
-            <a:pPr indent="0" marL="0">
-              <a:buNone/>
-            </a:pPr>
-            <a:r>
-              <a:rPr lang="en-US" sz="1200" b="1" dirty="0">
-                <a:solidFill>
-                  <a:srgbClr val="12192C"/>
-                </a:solidFill>
-                <a:latin typeface="Aptos" pitchFamily="34" charset="0"/>
-                <a:ea typeface="Aptos" pitchFamily="34" charset="-122"/>
-                <a:cs typeface="Aptos" pitchFamily="34" charset="-120"/>
-              </a:rPr>
-              <a:t>crosst niet tegen 2040</a:t>
-            </a:r>
-            <a:endParaRPr lang="en-US" sz="1200" dirty="0"/>
-          </a:p>
-        </p:txBody>
-      </p:sp>
-      <p:sp>
-        <p:nvSpPr>
-          <p:cNvPr id="21" name="Text 18"/>
-          <p:cNvSpPr/>
-          <p:nvPr/>
-        </p:nvSpPr>
-        <p:spPr>
-          <a:xfrm>
-            <a:off x="6912864" y="3017520"/>
-            <a:ext cx="2596896" cy="457200"/>
-          </a:xfrm>
-          <a:prstGeom prst="rect">
-            <a:avLst/>
-          </a:prstGeom>
-          <a:noFill/>
-          <a:ln/>
-        </p:spPr>
-        <p:txBody>
-          <a:bodyPr wrap="square" lIns="0" tIns="0" rIns="0" bIns="0" rtlCol="0" anchor="ctr">
-            <a:normAutofit/>
-          </a:bodyPr>
-          <a:lstStyle/>
-          <a:p>
-            <a:pPr indent="0" marL="0">
-              <a:buNone/>
-            </a:pPr>
-            <a:r>
-              <a:rPr lang="en-US" sz="1100" dirty="0">
-                <a:solidFill>
-                  <a:srgbClr val="5B6476"/>
-                </a:solidFill>
-                <a:latin typeface="Aptos" pitchFamily="34" charset="0"/>
-                <a:ea typeface="Aptos" pitchFamily="34" charset="-122"/>
-                <a:cs typeface="Aptos" pitchFamily="34" charset="-120"/>
-              </a:rPr>
-              <a:t>onder huidige aannames</a:t>
-            </a:r>
-            <a:endParaRPr lang="en-US" sz="1100" dirty="0"/>
-          </a:p>
-        </p:txBody>
-      </p:sp>
-      <p:sp>
-        <p:nvSpPr>
-          <p:cNvPr id="22" name="Shape 19"/>
-          <p:cNvSpPr/>
-          <p:nvPr/>
-        </p:nvSpPr>
-        <p:spPr>
-          <a:xfrm>
-            <a:off x="9912096" y="1920240"/>
-            <a:ext cx="1728216" cy="1828800"/>
-          </a:xfrm>
-          <a:prstGeom prst="roundRect">
-            <a:avLst>
-              <a:gd name="adj" fmla="val 3175"/>
-            </a:avLst>
-          </a:prstGeom>
-          <a:solidFill>
-            <a:srgbClr val="F7F8FB"/>
-          </a:solidFill>
-          <a:ln w="12700">
-            <a:solidFill>
-              <a:srgbClr val="D9DDE6"/>
-            </a:solidFill>
-            <a:prstDash val="solid"/>
-          </a:ln>
-        </p:spPr>
-      </p:sp>
-      <p:sp>
-        <p:nvSpPr>
-          <p:cNvPr id="23" name="Text 20"/>
-          <p:cNvSpPr/>
-          <p:nvPr/>
-        </p:nvSpPr>
-        <p:spPr>
-          <a:xfrm>
-            <a:off x="10113264" y="2139696"/>
-            <a:ext cx="1097280" cy="146304"/>
-          </a:xfrm>
-          <a:prstGeom prst="rect">
-            <a:avLst/>
-          </a:prstGeom>
-          <a:noFill/>
-          <a:ln/>
-        </p:spPr>
-        <p:txBody>
-          <a:bodyPr wrap="square" lIns="0" tIns="0" rIns="0" bIns="0" rtlCol="0" anchor="ctr">
-            <a:normAutofit/>
-          </a:bodyPr>
-          <a:lstStyle/>
-          <a:p>
-            <a:pPr indent="0" marL="0">
-              <a:buNone/>
-            </a:pPr>
-            <a:r>
-              <a:rPr lang="en-US" sz="1000" b="1" dirty="0">
-                <a:solidFill>
-                  <a:srgbClr val="5B6476"/>
-                </a:solidFill>
-                <a:latin typeface="Aptos" pitchFamily="34" charset="0"/>
-                <a:ea typeface="Aptos" pitchFamily="34" charset="-122"/>
-                <a:cs typeface="Aptos" pitchFamily="34" charset="-120"/>
-              </a:rPr>
-              <a:t>label</a:t>
-            </a:r>
-            <a:endParaRPr lang="en-US" sz="1000" dirty="0"/>
-          </a:p>
-        </p:txBody>
-      </p:sp>
-      <p:sp>
-        <p:nvSpPr>
-          <p:cNvPr id="24" name="Text 21"/>
-          <p:cNvSpPr/>
-          <p:nvPr/>
-        </p:nvSpPr>
-        <p:spPr>
-          <a:xfrm>
-            <a:off x="10113264" y="2432304"/>
-            <a:ext cx="1097280" cy="475488"/>
-          </a:xfrm>
-          <a:prstGeom prst="rect">
-            <a:avLst/>
-          </a:prstGeom>
-          <a:noFill/>
-          <a:ln/>
-        </p:spPr>
-        <p:txBody>
-          <a:bodyPr wrap="square" lIns="0" tIns="0" rIns="0" bIns="0" rtlCol="0" anchor="ctr">
-            <a:normAutofit/>
-          </a:bodyPr>
-          <a:lstStyle/>
-          <a:p>
-            <a:pPr indent="0" marL="0">
-              <a:buNone/>
-            </a:pPr>
-            <a:r>
-              <a:rPr lang="en-US" sz="1500" b="1" dirty="0">
-                <a:solidFill>
-                  <a:srgbClr val="E93325"/>
-                </a:solidFill>
-                <a:latin typeface="Aptos" pitchFamily="34" charset="0"/>
-                <a:ea typeface="Aptos" pitchFamily="34" charset="-122"/>
-                <a:cs typeface="Aptos" pitchFamily="34" charset="-120"/>
-              </a:rPr>
-              <a:t>assumptie-gedreven</a:t>
-            </a:r>
-            <a:endParaRPr lang="en-US" sz="1500" dirty="0"/>
-          </a:p>
-        </p:txBody>
-      </p:sp>
-      <p:sp>
-        <p:nvSpPr>
-          <p:cNvPr id="25" name="Shape 22"/>
-          <p:cNvSpPr/>
-          <p:nvPr/>
-        </p:nvSpPr>
-        <p:spPr>
-          <a:xfrm>
-            <a:off x="713232" y="4133088"/>
-            <a:ext cx="10927080" cy="1335024"/>
-          </a:xfrm>
-          <a:prstGeom prst="roundRect">
-            <a:avLst>
-              <a:gd name="adj" fmla="val 4110"/>
+              <a:gd name="adj" fmla="val 2804"/>
             </a:avLst>
           </a:prstGeom>
           <a:solidFill>
@@ -9636,14 +9226,14 @@
       </p:sp>
       <p:sp>
         <p:nvSpPr>
-          <p:cNvPr id="26" name="Text 23"/>
-          <p:cNvSpPr/>
-          <p:nvPr/>
-        </p:nvSpPr>
-        <p:spPr>
-          <a:xfrm>
-            <a:off x="932688" y="4407408"/>
-            <a:ext cx="2377440" cy="182880"/>
+          <p:cNvPr id="11" name="Text 8"/>
+          <p:cNvSpPr/>
+          <p:nvPr/>
+        </p:nvSpPr>
+        <p:spPr>
+          <a:xfrm>
+            <a:off x="987552" y="2212848"/>
+            <a:ext cx="2560320" cy="201168"/>
           </a:xfrm>
           <a:prstGeom prst="rect">
             <a:avLst/>
@@ -9677,55 +9267,96 @@
       </p:sp>
       <p:sp>
         <p:nvSpPr>
-          <p:cNvPr id="27" name="Text 24"/>
-          <p:cNvSpPr/>
-          <p:nvPr/>
-        </p:nvSpPr>
-        <p:spPr>
-          <a:xfrm>
-            <a:off x="932688" y="4718304"/>
-            <a:ext cx="9875520" cy="457200"/>
-          </a:xfrm>
-          <a:prstGeom prst="rect">
-            <a:avLst/>
-          </a:prstGeom>
-          <a:noFill/>
-          <a:ln/>
-        </p:spPr>
-        <p:txBody>
-          <a:bodyPr wrap="square" lIns="0" tIns="0" rIns="0" bIns="0" rtlCol="0" anchor="ctr">
-            <a:normAutofit/>
-          </a:bodyPr>
-          <a:lstStyle/>
-          <a:p>
-            <a:pPr indent="0" marL="0">
-              <a:buNone/>
-            </a:pPr>
-            <a:r>
-              <a:rPr lang="en-US" sz="1600" dirty="0">
+          <p:cNvPr id="12" name="Text 9"/>
+          <p:cNvSpPr/>
+          <p:nvPr/>
+        </p:nvSpPr>
+        <p:spPr>
+          <a:xfrm>
+            <a:off x="987552" y="2615184"/>
+            <a:ext cx="9875520" cy="310896"/>
+          </a:xfrm>
+          <a:prstGeom prst="rect">
+            <a:avLst/>
+          </a:prstGeom>
+          <a:noFill/>
+          <a:ln/>
+        </p:spPr>
+        <p:txBody>
+          <a:bodyPr wrap="square" lIns="0" tIns="0" rIns="0" bIns="0" rtlCol="0" anchor="ctr">
+            <a:normAutofit/>
+          </a:bodyPr>
+          <a:lstStyle/>
+          <a:p>
+            <a:pPr indent="0" marL="0">
+              <a:buNone/>
+            </a:pPr>
+            <a:r>
+              <a:rPr lang="en-US" sz="2400" b="1" dirty="0">
                 <a:solidFill>
                   <a:srgbClr val="FFFFFF"/>
                 </a:solidFill>
-                <a:latin typeface="Aptos" pitchFamily="34" charset="0"/>
-                <a:ea typeface="Aptos" pitchFamily="34" charset="-122"/>
-                <a:cs typeface="Aptos" pitchFamily="34" charset="-120"/>
-              </a:rPr>
-              <a:t>In deze parameterisatie binden floors eerder dan de headline threshold. Dus memory, reliability, network en governance wegen zwaarder dan één headline-getal.</a:t>
-            </a:r>
-            <a:endParaRPr lang="en-US" sz="1600" dirty="0"/>
-          </a:p>
-        </p:txBody>
-      </p:sp>
-      <p:sp>
-        <p:nvSpPr>
-          <p:cNvPr id="28" name="Shape 25"/>
-          <p:cNvSpPr/>
-          <p:nvPr/>
-        </p:nvSpPr>
-        <p:spPr>
-          <a:xfrm>
-            <a:off x="932688" y="5138928"/>
-            <a:ext cx="822960" cy="329184"/>
+                <a:latin typeface="Aptos Display" pitchFamily="34" charset="0"/>
+                <a:ea typeface="Aptos Display" pitchFamily="34" charset="-122"/>
+                <a:cs typeface="Aptos Display" pitchFamily="34" charset="-120"/>
+              </a:rPr>
+              <a:t>In deze parameterisatie binden floors eerder dan de headline threshold.</a:t>
+            </a:r>
+            <a:endParaRPr lang="en-US" sz="2400" dirty="0"/>
+          </a:p>
+        </p:txBody>
+      </p:sp>
+      <p:sp>
+        <p:nvSpPr>
+          <p:cNvPr id="13" name="Text 10"/>
+          <p:cNvSpPr/>
+          <p:nvPr/>
+        </p:nvSpPr>
+        <p:spPr>
+          <a:xfrm>
+            <a:off x="987552" y="3072384"/>
+            <a:ext cx="9875520" cy="256032"/>
+          </a:xfrm>
+          <a:prstGeom prst="rect">
+            <a:avLst/>
+          </a:prstGeom>
+          <a:noFill/>
+          <a:ln/>
+        </p:spPr>
+        <p:txBody>
+          <a:bodyPr wrap="square" lIns="0" tIns="0" rIns="0" bIns="0" rtlCol="0" anchor="ctr">
+            <a:normAutofit/>
+          </a:bodyPr>
+          <a:lstStyle/>
+          <a:p>
+            <a:pPr indent="0" marL="0">
+              <a:buNone/>
+            </a:pPr>
+            <a:r>
+              <a:rPr lang="en-US" sz="1700" b="1" dirty="0">
+                <a:solidFill>
+                  <a:srgbClr val="D7DCE7"/>
+                </a:solidFill>
+                <a:latin typeface="Aptos" pitchFamily="34" charset="0"/>
+                <a:ea typeface="Aptos" pitchFamily="34" charset="-122"/>
+                <a:cs typeface="Aptos" pitchFamily="34" charset="-120"/>
+              </a:rPr>
+              <a:t>Dus memory, reliability, network en governance wegen zwaarder dan één headline-getal.</a:t>
+            </a:r>
+            <a:endParaRPr lang="en-US" sz="1700" dirty="0"/>
+          </a:p>
+        </p:txBody>
+      </p:sp>
+      <p:sp>
+        <p:nvSpPr>
+          <p:cNvPr id="14" name="Shape 11"/>
+          <p:cNvSpPr/>
+          <p:nvPr/>
+        </p:nvSpPr>
+        <p:spPr>
+          <a:xfrm>
+            <a:off x="987552" y="3456432"/>
+            <a:ext cx="1005840" cy="329184"/>
           </a:xfrm>
           <a:prstGeom prst="roundRect">
             <a:avLst>
@@ -9747,14 +9378,14 @@
       </p:sp>
       <p:sp>
         <p:nvSpPr>
-          <p:cNvPr id="29" name="Text 26"/>
-          <p:cNvSpPr/>
-          <p:nvPr/>
-        </p:nvSpPr>
-        <p:spPr>
-          <a:xfrm>
-            <a:off x="1078992" y="5212080"/>
-            <a:ext cx="530352" cy="164592"/>
+          <p:cNvPr id="15" name="Text 12"/>
+          <p:cNvSpPr/>
+          <p:nvPr/>
+        </p:nvSpPr>
+        <p:spPr>
+          <a:xfrm>
+            <a:off x="1133856" y="3529584"/>
+            <a:ext cx="713232" cy="164592"/>
           </a:xfrm>
           <a:prstGeom prst="rect">
             <a:avLst/>
@@ -9788,14 +9419,14 @@
       </p:sp>
       <p:sp>
         <p:nvSpPr>
-          <p:cNvPr id="30" name="Shape 27"/>
-          <p:cNvSpPr/>
-          <p:nvPr/>
-        </p:nvSpPr>
-        <p:spPr>
-          <a:xfrm>
-            <a:off x="1847088" y="5138928"/>
-            <a:ext cx="932688" cy="329184"/>
+          <p:cNvPr id="16" name="Shape 13"/>
+          <p:cNvSpPr/>
+          <p:nvPr/>
+        </p:nvSpPr>
+        <p:spPr>
+          <a:xfrm>
+            <a:off x="2121408" y="3456432"/>
+            <a:ext cx="1097280" cy="329184"/>
           </a:xfrm>
           <a:prstGeom prst="roundRect">
             <a:avLst>
@@ -9817,14 +9448,14 @@
       </p:sp>
       <p:sp>
         <p:nvSpPr>
-          <p:cNvPr id="31" name="Text 28"/>
-          <p:cNvSpPr/>
-          <p:nvPr/>
-        </p:nvSpPr>
-        <p:spPr>
-          <a:xfrm>
-            <a:off x="1993392" y="5212080"/>
-            <a:ext cx="640080" cy="164592"/>
+          <p:cNvPr id="17" name="Text 14"/>
+          <p:cNvSpPr/>
+          <p:nvPr/>
+        </p:nvSpPr>
+        <p:spPr>
+          <a:xfrm>
+            <a:off x="2267712" y="3529584"/>
+            <a:ext cx="804672" cy="164592"/>
           </a:xfrm>
           <a:prstGeom prst="rect">
             <a:avLst/>
@@ -9858,14 +9489,14 @@
       </p:sp>
       <p:sp>
         <p:nvSpPr>
-          <p:cNvPr id="32" name="Shape 29"/>
-          <p:cNvSpPr/>
-          <p:nvPr/>
-        </p:nvSpPr>
-        <p:spPr>
-          <a:xfrm>
-            <a:off x="2889504" y="5138928"/>
-            <a:ext cx="841248" cy="329184"/>
+          <p:cNvPr id="18" name="Shape 15"/>
+          <p:cNvSpPr/>
+          <p:nvPr/>
+        </p:nvSpPr>
+        <p:spPr>
+          <a:xfrm>
+            <a:off x="3346704" y="3456432"/>
+            <a:ext cx="987552" cy="329184"/>
           </a:xfrm>
           <a:prstGeom prst="roundRect">
             <a:avLst>
@@ -9887,14 +9518,14 @@
       </p:sp>
       <p:sp>
         <p:nvSpPr>
-          <p:cNvPr id="33" name="Text 30"/>
-          <p:cNvSpPr/>
-          <p:nvPr/>
-        </p:nvSpPr>
-        <p:spPr>
-          <a:xfrm>
-            <a:off x="3035808" y="5212080"/>
-            <a:ext cx="548640" cy="164592"/>
+          <p:cNvPr id="19" name="Text 16"/>
+          <p:cNvSpPr/>
+          <p:nvPr/>
+        </p:nvSpPr>
+        <p:spPr>
+          <a:xfrm>
+            <a:off x="3493008" y="3529584"/>
+            <a:ext cx="694944" cy="164592"/>
           </a:xfrm>
           <a:prstGeom prst="rect">
             <a:avLst/>
@@ -9928,14 +9559,14 @@
       </p:sp>
       <p:sp>
         <p:nvSpPr>
-          <p:cNvPr id="34" name="Shape 31"/>
-          <p:cNvSpPr/>
-          <p:nvPr/>
-        </p:nvSpPr>
-        <p:spPr>
-          <a:xfrm>
-            <a:off x="3822192" y="5138928"/>
-            <a:ext cx="1024128" cy="329184"/>
+          <p:cNvPr id="20" name="Shape 17"/>
+          <p:cNvSpPr/>
+          <p:nvPr/>
+        </p:nvSpPr>
+        <p:spPr>
+          <a:xfrm>
+            <a:off x="4462272" y="3456432"/>
+            <a:ext cx="1170432" cy="329184"/>
           </a:xfrm>
           <a:prstGeom prst="roundRect">
             <a:avLst>
@@ -9957,54 +9588,613 @@
       </p:sp>
       <p:sp>
         <p:nvSpPr>
+          <p:cNvPr id="21" name="Text 18"/>
+          <p:cNvSpPr/>
+          <p:nvPr/>
+        </p:nvSpPr>
+        <p:spPr>
+          <a:xfrm>
+            <a:off x="4608576" y="3529584"/>
+            <a:ext cx="877824" cy="164592"/>
+          </a:xfrm>
+          <a:prstGeom prst="rect">
+            <a:avLst/>
+          </a:prstGeom>
+          <a:noFill/>
+          <a:ln/>
+        </p:spPr>
+        <p:txBody>
+          <a:bodyPr wrap="square" lIns="0" tIns="0" rIns="0" bIns="0" rtlCol="0" anchor="ctr">
+            <a:normAutofit/>
+          </a:bodyPr>
+          <a:lstStyle/>
+          <a:p>
+            <a:pPr indent="0" marL="0">
+              <a:buNone/>
+            </a:pPr>
+            <a:r>
+              <a:rPr lang="en-US" sz="900" b="1" dirty="0">
+                <a:solidFill>
+                  <a:srgbClr val="FFFFFF"/>
+                </a:solidFill>
+                <a:latin typeface="Aptos" pitchFamily="34" charset="0"/>
+                <a:ea typeface="Aptos" pitchFamily="34" charset="-122"/>
+                <a:cs typeface="Aptos" pitchFamily="34" charset="-120"/>
+              </a:rPr>
+              <a:t>governance</a:t>
+            </a:r>
+            <a:endParaRPr lang="en-US" sz="900" dirty="0"/>
+          </a:p>
+        </p:txBody>
+      </p:sp>
+      <p:sp>
+        <p:nvSpPr>
+          <p:cNvPr id="22" name="Shape 19"/>
+          <p:cNvSpPr/>
+          <p:nvPr/>
+        </p:nvSpPr>
+        <p:spPr>
+          <a:xfrm>
+            <a:off x="713232" y="4187952"/>
+            <a:ext cx="3054096" cy="1828800"/>
+          </a:xfrm>
+          <a:prstGeom prst="roundRect">
+            <a:avLst>
+              <a:gd name="adj" fmla="val 3000"/>
+            </a:avLst>
+          </a:prstGeom>
+          <a:solidFill>
+            <a:srgbClr val="F7F8FB"/>
+          </a:solidFill>
+          <a:ln w="12700">
+            <a:solidFill>
+              <a:srgbClr val="D9DDE6"/>
+            </a:solidFill>
+            <a:prstDash val="solid"/>
+          </a:ln>
+        </p:spPr>
+      </p:sp>
+      <p:sp>
+        <p:nvSpPr>
+          <p:cNvPr id="23" name="Text 20"/>
+          <p:cNvSpPr/>
+          <p:nvPr/>
+        </p:nvSpPr>
+        <p:spPr>
+          <a:xfrm>
+            <a:off x="896112" y="4370832"/>
+            <a:ext cx="2688336" cy="502920"/>
+          </a:xfrm>
+          <a:prstGeom prst="rect">
+            <a:avLst/>
+          </a:prstGeom>
+          <a:noFill/>
+          <a:ln/>
+        </p:spPr>
+        <p:txBody>
+          <a:bodyPr wrap="square" lIns="0" tIns="0" rIns="0" bIns="0" rtlCol="0" anchor="ctr">
+            <a:normAutofit/>
+          </a:bodyPr>
+          <a:lstStyle/>
+          <a:p>
+            <a:pPr indent="0" marL="0">
+              <a:buNone/>
+            </a:pPr>
+            <a:r>
+              <a:rPr lang="en-US" sz="2800" b="1" dirty="0">
+                <a:solidFill>
+                  <a:srgbClr val="E93325"/>
+                </a:solidFill>
+                <a:latin typeface="Aptos Display" pitchFamily="34" charset="0"/>
+                <a:ea typeface="Aptos Display" pitchFamily="34" charset="-122"/>
+                <a:cs typeface="Aptos Display" pitchFamily="34" charset="-120"/>
+              </a:rPr>
+              <a:t>28,1%</a:t>
+            </a:r>
+            <a:endParaRPr lang="en-US" sz="2800" dirty="0"/>
+          </a:p>
+        </p:txBody>
+      </p:sp>
+      <p:sp>
+        <p:nvSpPr>
+          <p:cNvPr id="24" name="Text 21"/>
+          <p:cNvSpPr/>
+          <p:nvPr/>
+        </p:nvSpPr>
+        <p:spPr>
+          <a:xfrm>
+            <a:off x="896112" y="4974336"/>
+            <a:ext cx="2688336" cy="237744"/>
+          </a:xfrm>
+          <a:prstGeom prst="rect">
+            <a:avLst/>
+          </a:prstGeom>
+          <a:noFill/>
+          <a:ln/>
+        </p:spPr>
+        <p:txBody>
+          <a:bodyPr wrap="square" lIns="0" tIns="0" rIns="0" bIns="0" rtlCol="0" anchor="ctr">
+            <a:normAutofit/>
+          </a:bodyPr>
+          <a:lstStyle/>
+          <a:p>
+            <a:pPr indent="0" marL="0">
+              <a:buNone/>
+            </a:pPr>
+            <a:r>
+              <a:rPr lang="en-US" sz="1200" b="1" dirty="0">
+                <a:solidFill>
+                  <a:srgbClr val="12192C"/>
+                </a:solidFill>
+                <a:latin typeface="Aptos" pitchFamily="34" charset="0"/>
+                <a:ea typeface="Aptos" pitchFamily="34" charset="-122"/>
+                <a:cs typeface="Aptos" pitchFamily="34" charset="-120"/>
+              </a:rPr>
+              <a:t>basisscenario tegen 2040</a:t>
+            </a:r>
+            <a:endParaRPr lang="en-US" sz="1200" dirty="0"/>
+          </a:p>
+        </p:txBody>
+      </p:sp>
+      <p:sp>
+        <p:nvSpPr>
+          <p:cNvPr id="25" name="Text 22"/>
+          <p:cNvSpPr/>
+          <p:nvPr/>
+        </p:nvSpPr>
+        <p:spPr>
+          <a:xfrm>
+            <a:off x="896112" y="5285232"/>
+            <a:ext cx="2688336" cy="457200"/>
+          </a:xfrm>
+          <a:prstGeom prst="rect">
+            <a:avLst/>
+          </a:prstGeom>
+          <a:noFill/>
+          <a:ln/>
+        </p:spPr>
+        <p:txBody>
+          <a:bodyPr wrap="square" lIns="0" tIns="0" rIns="0" bIns="0" rtlCol="0" anchor="ctr">
+            <a:normAutofit/>
+          </a:bodyPr>
+          <a:lstStyle/>
+          <a:p>
+            <a:pPr indent="0" marL="0">
+              <a:buNone/>
+            </a:pPr>
+            <a:r>
+              <a:rPr lang="en-US" sz="1100" dirty="0">
+                <a:solidFill>
+                  <a:srgbClr val="5B6476"/>
+                </a:solidFill>
+                <a:latin typeface="Aptos" pitchFamily="34" charset="0"/>
+                <a:ea typeface="Aptos" pitchFamily="34" charset="-122"/>
+                <a:cs typeface="Aptos" pitchFamily="34" charset="-120"/>
+              </a:rPr>
+              <a:t>onder huidige aannames</a:t>
+            </a:r>
+            <a:endParaRPr lang="en-US" sz="1100" dirty="0"/>
+          </a:p>
+        </p:txBody>
+      </p:sp>
+      <p:sp>
+        <p:nvSpPr>
+          <p:cNvPr id="26" name="Shape 23"/>
+          <p:cNvSpPr/>
+          <p:nvPr/>
+        </p:nvSpPr>
+        <p:spPr>
+          <a:xfrm>
+            <a:off x="3968496" y="4187952"/>
+            <a:ext cx="2743200" cy="1828800"/>
+          </a:xfrm>
+          <a:prstGeom prst="roundRect">
+            <a:avLst>
+              <a:gd name="adj" fmla="val 3000"/>
+            </a:avLst>
+          </a:prstGeom>
+          <a:solidFill>
+            <a:srgbClr val="F7F8FB"/>
+          </a:solidFill>
+          <a:ln w="12700">
+            <a:solidFill>
+              <a:srgbClr val="D9DDE6"/>
+            </a:solidFill>
+            <a:prstDash val="solid"/>
+          </a:ln>
+        </p:spPr>
+      </p:sp>
+      <p:sp>
+        <p:nvSpPr>
+          <p:cNvPr id="27" name="Text 24"/>
+          <p:cNvSpPr/>
+          <p:nvPr/>
+        </p:nvSpPr>
+        <p:spPr>
+          <a:xfrm>
+            <a:off x="4151376" y="4370832"/>
+            <a:ext cx="2377440" cy="502920"/>
+          </a:xfrm>
+          <a:prstGeom prst="rect">
+            <a:avLst/>
+          </a:prstGeom>
+          <a:noFill/>
+          <a:ln/>
+        </p:spPr>
+        <p:txBody>
+          <a:bodyPr wrap="square" lIns="0" tIns="0" rIns="0" bIns="0" rtlCol="0" anchor="ctr">
+            <a:normAutofit/>
+          </a:bodyPr>
+          <a:lstStyle/>
+          <a:p>
+            <a:pPr indent="0" marL="0">
+              <a:buNone/>
+            </a:pPr>
+            <a:r>
+              <a:rPr lang="en-US" sz="2800" b="1" dirty="0">
+                <a:solidFill>
+                  <a:srgbClr val="F2AD18"/>
+                </a:solidFill>
+                <a:latin typeface="Aptos Display" pitchFamily="34" charset="0"/>
+                <a:ea typeface="Aptos Display" pitchFamily="34" charset="-122"/>
+                <a:cs typeface="Aptos Display" pitchFamily="34" charset="-120"/>
+              </a:rPr>
+              <a:t>2038</a:t>
+            </a:r>
+            <a:endParaRPr lang="en-US" sz="2800" dirty="0"/>
+          </a:p>
+        </p:txBody>
+      </p:sp>
+      <p:sp>
+        <p:nvSpPr>
+          <p:cNvPr id="28" name="Text 25"/>
+          <p:cNvSpPr/>
+          <p:nvPr/>
+        </p:nvSpPr>
+        <p:spPr>
+          <a:xfrm>
+            <a:off x="4151376" y="4974336"/>
+            <a:ext cx="2377440" cy="237744"/>
+          </a:xfrm>
+          <a:prstGeom prst="rect">
+            <a:avLst/>
+          </a:prstGeom>
+          <a:noFill/>
+          <a:ln/>
+        </p:spPr>
+        <p:txBody>
+          <a:bodyPr wrap="square" lIns="0" tIns="0" rIns="0" bIns="0" rtlCol="0" anchor="ctr">
+            <a:normAutofit/>
+          </a:bodyPr>
+          <a:lstStyle/>
+          <a:p>
+            <a:pPr indent="0" marL="0">
+              <a:buNone/>
+            </a:pPr>
+            <a:r>
+              <a:rPr lang="en-US" sz="1200" b="1" dirty="0">
+                <a:solidFill>
+                  <a:srgbClr val="12192C"/>
+                </a:solidFill>
+                <a:latin typeface="Aptos" pitchFamily="34" charset="0"/>
+                <a:ea typeface="Aptos" pitchFamily="34" charset="-122"/>
+                <a:cs typeface="Aptos" pitchFamily="34" charset="-120"/>
+              </a:rPr>
+              <a:t>mediaan in basisscenario</a:t>
+            </a:r>
+            <a:endParaRPr lang="en-US" sz="1200" dirty="0"/>
+          </a:p>
+        </p:txBody>
+      </p:sp>
+      <p:sp>
+        <p:nvSpPr>
+          <p:cNvPr id="29" name="Text 26"/>
+          <p:cNvSpPr/>
+          <p:nvPr/>
+        </p:nvSpPr>
+        <p:spPr>
+          <a:xfrm>
+            <a:off x="4151376" y="5285232"/>
+            <a:ext cx="2377440" cy="457200"/>
+          </a:xfrm>
+          <a:prstGeom prst="rect">
+            <a:avLst/>
+          </a:prstGeom>
+          <a:noFill/>
+          <a:ln/>
+        </p:spPr>
+        <p:txBody>
+          <a:bodyPr wrap="square" lIns="0" tIns="0" rIns="0" bIns="0" rtlCol="0" anchor="ctr">
+            <a:normAutofit/>
+          </a:bodyPr>
+          <a:lstStyle/>
+          <a:p>
+            <a:pPr indent="0" marL="0">
+              <a:buNone/>
+            </a:pPr>
+            <a:r>
+              <a:rPr lang="en-US" sz="1100" dirty="0">
+                <a:solidFill>
+                  <a:srgbClr val="5B6476"/>
+                </a:solidFill>
+                <a:latin typeface="Aptos" pitchFamily="34" charset="0"/>
+                <a:ea typeface="Aptos" pitchFamily="34" charset="-122"/>
+                <a:cs typeface="Aptos" pitchFamily="34" charset="-120"/>
+              </a:rPr>
+              <a:t>geen datum-belofte</a:t>
+            </a:r>
+            <a:endParaRPr lang="en-US" sz="1100" dirty="0"/>
+          </a:p>
+        </p:txBody>
+      </p:sp>
+      <p:sp>
+        <p:nvSpPr>
+          <p:cNvPr id="30" name="Shape 27"/>
+          <p:cNvSpPr/>
+          <p:nvPr/>
+        </p:nvSpPr>
+        <p:spPr>
+          <a:xfrm>
+            <a:off x="6912864" y="4187952"/>
+            <a:ext cx="2560320" cy="1828800"/>
+          </a:xfrm>
+          <a:prstGeom prst="roundRect">
+            <a:avLst>
+              <a:gd name="adj" fmla="val 3000"/>
+            </a:avLst>
+          </a:prstGeom>
+          <a:solidFill>
+            <a:srgbClr val="F7F8FB"/>
+          </a:solidFill>
+          <a:ln w="12700">
+            <a:solidFill>
+              <a:srgbClr val="D9DDE6"/>
+            </a:solidFill>
+            <a:prstDash val="solid"/>
+          </a:ln>
+        </p:spPr>
+      </p:sp>
+      <p:sp>
+        <p:nvSpPr>
+          <p:cNvPr id="31" name="Text 28"/>
+          <p:cNvSpPr/>
+          <p:nvPr/>
+        </p:nvSpPr>
+        <p:spPr>
+          <a:xfrm>
+            <a:off x="7095744" y="4370832"/>
+            <a:ext cx="2194560" cy="502920"/>
+          </a:xfrm>
+          <a:prstGeom prst="rect">
+            <a:avLst/>
+          </a:prstGeom>
+          <a:noFill/>
+          <a:ln/>
+        </p:spPr>
+        <p:txBody>
+          <a:bodyPr wrap="square" lIns="0" tIns="0" rIns="0" bIns="0" rtlCol="0" anchor="ctr">
+            <a:normAutofit/>
+          </a:bodyPr>
+          <a:lstStyle/>
+          <a:p>
+            <a:pPr indent="0" marL="0">
+              <a:buNone/>
+            </a:pPr>
+            <a:r>
+              <a:rPr lang="en-US" sz="2800" b="1" dirty="0">
+                <a:solidFill>
+                  <a:srgbClr val="0F766E"/>
+                </a:solidFill>
+                <a:latin typeface="Aptos Display" pitchFamily="34" charset="0"/>
+                <a:ea typeface="Aptos Display" pitchFamily="34" charset="-122"/>
+                <a:cs typeface="Aptos Display" pitchFamily="34" charset="-120"/>
+              </a:rPr>
+              <a:t>71,9%</a:t>
+            </a:r>
+            <a:endParaRPr lang="en-US" sz="2800" dirty="0"/>
+          </a:p>
+        </p:txBody>
+      </p:sp>
+      <p:sp>
+        <p:nvSpPr>
+          <p:cNvPr id="32" name="Text 29"/>
+          <p:cNvSpPr/>
+          <p:nvPr/>
+        </p:nvSpPr>
+        <p:spPr>
+          <a:xfrm>
+            <a:off x="7095744" y="4974336"/>
+            <a:ext cx="2194560" cy="237744"/>
+          </a:xfrm>
+          <a:prstGeom prst="rect">
+            <a:avLst/>
+          </a:prstGeom>
+          <a:noFill/>
+          <a:ln/>
+        </p:spPr>
+        <p:txBody>
+          <a:bodyPr wrap="square" lIns="0" tIns="0" rIns="0" bIns="0" rtlCol="0" anchor="ctr">
+            <a:normAutofit/>
+          </a:bodyPr>
+          <a:lstStyle/>
+          <a:p>
+            <a:pPr indent="0" marL="0">
+              <a:buNone/>
+            </a:pPr>
+            <a:r>
+              <a:rPr lang="en-US" sz="1200" b="1" dirty="0">
+                <a:solidFill>
+                  <a:srgbClr val="12192C"/>
+                </a:solidFill>
+                <a:latin typeface="Aptos" pitchFamily="34" charset="0"/>
+                <a:ea typeface="Aptos" pitchFamily="34" charset="-122"/>
+                <a:cs typeface="Aptos" pitchFamily="34" charset="-120"/>
+              </a:rPr>
+              <a:t>haalt drempel niet</a:t>
+            </a:r>
+            <a:endParaRPr lang="en-US" sz="1200" dirty="0"/>
+          </a:p>
+        </p:txBody>
+      </p:sp>
+      <p:sp>
+        <p:nvSpPr>
+          <p:cNvPr id="33" name="Text 30"/>
+          <p:cNvSpPr/>
+          <p:nvPr/>
+        </p:nvSpPr>
+        <p:spPr>
+          <a:xfrm>
+            <a:off x="7095744" y="5285232"/>
+            <a:ext cx="2194560" cy="457200"/>
+          </a:xfrm>
+          <a:prstGeom prst="rect">
+            <a:avLst/>
+          </a:prstGeom>
+          <a:noFill/>
+          <a:ln/>
+        </p:spPr>
+        <p:txBody>
+          <a:bodyPr wrap="square" lIns="0" tIns="0" rIns="0" bIns="0" rtlCol="0" anchor="ctr">
+            <a:normAutofit/>
+          </a:bodyPr>
+          <a:lstStyle/>
+          <a:p>
+            <a:pPr indent="0" marL="0">
+              <a:buNone/>
+            </a:pPr>
+            <a:r>
+              <a:rPr lang="en-US" sz="1100" dirty="0">
+                <a:solidFill>
+                  <a:srgbClr val="5B6476"/>
+                </a:solidFill>
+                <a:latin typeface="Aptos" pitchFamily="34" charset="0"/>
+                <a:ea typeface="Aptos" pitchFamily="34" charset="-122"/>
+                <a:cs typeface="Aptos" pitchFamily="34" charset="-120"/>
+              </a:rPr>
+              <a:t>tegen 2040</a:t>
+            </a:r>
+            <a:endParaRPr lang="en-US" sz="1100" dirty="0"/>
+          </a:p>
+        </p:txBody>
+      </p:sp>
+      <p:sp>
+        <p:nvSpPr>
+          <p:cNvPr id="34" name="Shape 31"/>
+          <p:cNvSpPr/>
+          <p:nvPr/>
+        </p:nvSpPr>
+        <p:spPr>
+          <a:xfrm>
+            <a:off x="9674352" y="4187952"/>
+            <a:ext cx="1965960" cy="1828800"/>
+          </a:xfrm>
+          <a:prstGeom prst="roundRect">
+            <a:avLst>
+              <a:gd name="adj" fmla="val 3000"/>
+            </a:avLst>
+          </a:prstGeom>
+          <a:solidFill>
+            <a:srgbClr val="F7F8FB"/>
+          </a:solidFill>
+          <a:ln w="12700">
+            <a:solidFill>
+              <a:srgbClr val="D9DDE6"/>
+            </a:solidFill>
+            <a:prstDash val="solid"/>
+          </a:ln>
+        </p:spPr>
+      </p:sp>
+      <p:sp>
+        <p:nvSpPr>
           <p:cNvPr id="35" name="Text 32"/>
           <p:cNvSpPr/>
           <p:nvPr/>
         </p:nvSpPr>
         <p:spPr>
           <a:xfrm>
-            <a:off x="3968496" y="5212080"/>
-            <a:ext cx="731520" cy="164592"/>
-          </a:xfrm>
-          <a:prstGeom prst="rect">
-            <a:avLst/>
-          </a:prstGeom>
-          <a:noFill/>
-          <a:ln/>
-        </p:spPr>
-        <p:txBody>
-          <a:bodyPr wrap="square" lIns="0" tIns="0" rIns="0" bIns="0" rtlCol="0" anchor="ctr">
-            <a:normAutofit/>
-          </a:bodyPr>
-          <a:lstStyle/>
-          <a:p>
-            <a:pPr indent="0" marL="0">
-              <a:buNone/>
-            </a:pPr>
-            <a:r>
-              <a:rPr lang="en-US" sz="900" b="1" dirty="0">
-                <a:solidFill>
-                  <a:srgbClr val="FFFFFF"/>
-                </a:solidFill>
-                <a:latin typeface="Aptos" pitchFamily="34" charset="0"/>
-                <a:ea typeface="Aptos" pitchFamily="34" charset="-122"/>
-                <a:cs typeface="Aptos" pitchFamily="34" charset="-120"/>
-              </a:rPr>
-              <a:t>governance</a:t>
-            </a:r>
-            <a:endParaRPr lang="en-US" sz="900" dirty="0"/>
-          </a:p>
-        </p:txBody>
-      </p:sp>
-      <p:sp>
-        <p:nvSpPr>
-          <p:cNvPr id="36" name="Shape 33"/>
-          <p:cNvSpPr/>
-          <p:nvPr/>
-        </p:nvSpPr>
-        <p:spPr>
-          <a:xfrm>
-            <a:off x="713232" y="5559552"/>
+            <a:off x="9893808" y="4425696"/>
+            <a:ext cx="1097280" cy="146304"/>
+          </a:xfrm>
+          <a:prstGeom prst="rect">
+            <a:avLst/>
+          </a:prstGeom>
+          <a:noFill/>
+          <a:ln/>
+        </p:spPr>
+        <p:txBody>
+          <a:bodyPr wrap="square" lIns="0" tIns="0" rIns="0" bIns="0" rtlCol="0" anchor="ctr">
+            <a:normAutofit/>
+          </a:bodyPr>
+          <a:lstStyle/>
+          <a:p>
+            <a:pPr indent="0" marL="0">
+              <a:buNone/>
+            </a:pPr>
+            <a:r>
+              <a:rPr lang="en-US" sz="1000" b="1" dirty="0">
+                <a:solidFill>
+                  <a:srgbClr val="5B6476"/>
+                </a:solidFill>
+                <a:latin typeface="Aptos" pitchFamily="34" charset="0"/>
+                <a:ea typeface="Aptos" pitchFamily="34" charset="-122"/>
+                <a:cs typeface="Aptos" pitchFamily="34" charset="-120"/>
+              </a:rPr>
+              <a:t>label</a:t>
+            </a:r>
+            <a:endParaRPr lang="en-US" sz="1000" dirty="0"/>
+          </a:p>
+        </p:txBody>
+      </p:sp>
+      <p:sp>
+        <p:nvSpPr>
+          <p:cNvPr id="36" name="Text 33"/>
+          <p:cNvSpPr/>
+          <p:nvPr/>
+        </p:nvSpPr>
+        <p:spPr>
+          <a:xfrm>
+            <a:off x="9893808" y="4736592"/>
+            <a:ext cx="1371600" cy="329184"/>
+          </a:xfrm>
+          <a:prstGeom prst="rect">
+            <a:avLst/>
+          </a:prstGeom>
+          <a:noFill/>
+          <a:ln/>
+        </p:spPr>
+        <p:txBody>
+          <a:bodyPr wrap="square" lIns="0" tIns="0" rIns="0" bIns="0" rtlCol="0" anchor="ctr">
+            <a:normAutofit/>
+          </a:bodyPr>
+          <a:lstStyle/>
+          <a:p>
+            <a:pPr indent="0" marL="0">
+              <a:buNone/>
+            </a:pPr>
+            <a:r>
+              <a:rPr lang="en-US" sz="1500" b="1" dirty="0">
+                <a:solidFill>
+                  <a:srgbClr val="E93325"/>
+                </a:solidFill>
+                <a:latin typeface="Aptos" pitchFamily="34" charset="0"/>
+                <a:ea typeface="Aptos" pitchFamily="34" charset="-122"/>
+                <a:cs typeface="Aptos" pitchFamily="34" charset="-120"/>
+              </a:rPr>
+              <a:t>assumptie-gedreven</a:t>
+            </a:r>
+            <a:endParaRPr lang="en-US" sz="1500" dirty="0"/>
+          </a:p>
+        </p:txBody>
+      </p:sp>
+      <p:sp>
+        <p:nvSpPr>
+          <p:cNvPr id="37" name="Shape 34"/>
+          <p:cNvSpPr/>
+          <p:nvPr/>
+        </p:nvSpPr>
+        <p:spPr>
+          <a:xfrm>
+            <a:off x="713232" y="5596128"/>
             <a:ext cx="10927080" cy="640080"/>
           </a:xfrm>
           <a:prstGeom prst="roundRect">
@@ -10025,13 +10215,13 @@
       </p:sp>
       <p:sp>
         <p:nvSpPr>
-          <p:cNvPr id="37" name="Text 34"/>
-          <p:cNvSpPr/>
-          <p:nvPr/>
-        </p:nvSpPr>
-        <p:spPr>
-          <a:xfrm>
-            <a:off x="932688" y="5724144"/>
+          <p:cNvPr id="38" name="Text 35"/>
+          <p:cNvSpPr/>
+          <p:nvPr/>
+        </p:nvSpPr>
+        <p:spPr>
+          <a:xfrm>
+            <a:off x="932688" y="5760720"/>
             <a:ext cx="10469880" cy="201168"/>
           </a:xfrm>
           <a:prstGeom prst="rect">
@@ -10058,7 +10248,7 @@
                 <a:ea typeface="Aptos" pitchFamily="34" charset="-122"/>
                 <a:cs typeface="Aptos" pitchFamily="34" charset="-120"/>
               </a:rPr>
-              <a:t>Takeaway: gebruik dit model om onzekerheid te ordenen, niet om 2038 als lot uit te spreken.</a:t>
+              <a:t>Takeaway: gebruik dit model om bottlenecks te ordenen, niet om 2038 als lot uit te spreken.</a:t>
             </a:r>
             <a:endParaRPr lang="en-US" sz="1200" dirty="0"/>
           </a:p>
@@ -10326,36 +10516,36 @@
         </p:nvSpPr>
         <p:spPr>
           <a:xfrm>
-            <a:off x="713232" y="1170432"/>
-            <a:ext cx="5486400" cy="219456"/>
-          </a:xfrm>
-          <a:prstGeom prst="rect">
-            <a:avLst/>
-          </a:prstGeom>
-          <a:noFill/>
-          <a:ln/>
-        </p:spPr>
-        <p:txBody>
-          <a:bodyPr wrap="square" lIns="0" tIns="0" rIns="0" bIns="0" rtlCol="0" anchor="ctr">
-            <a:normAutofit/>
-          </a:bodyPr>
-          <a:lstStyle/>
-          <a:p>
-            <a:pPr indent="0" marL="0">
-              <a:buNone/>
-            </a:pPr>
-            <a:r>
-              <a:rPr lang="en-US" sz="1500" dirty="0">
-                <a:solidFill>
-                  <a:srgbClr val="D7DCE7"/>
-                </a:solidFill>
-                <a:latin typeface="Aptos" pitchFamily="34" charset="0"/>
-                <a:ea typeface="Aptos" pitchFamily="34" charset="-122"/>
-                <a:cs typeface="Aptos" pitchFamily="34" charset="-120"/>
+            <a:off x="713232" y="1133856"/>
+            <a:ext cx="6949440" cy="329184"/>
+          </a:xfrm>
+          <a:prstGeom prst="rect">
+            <a:avLst/>
+          </a:prstGeom>
+          <a:noFill/>
+          <a:ln/>
+        </p:spPr>
+        <p:txBody>
+          <a:bodyPr wrap="square" lIns="0" tIns="0" rIns="0" bIns="0" rtlCol="0" anchor="ctr">
+            <a:normAutofit/>
+          </a:bodyPr>
+          <a:lstStyle/>
+          <a:p>
+            <a:pPr indent="0" marL="0">
+              <a:buNone/>
+            </a:pPr>
+            <a:r>
+              <a:rPr lang="en-US" sz="2200" b="1" dirty="0">
+                <a:solidFill>
+                  <a:srgbClr val="F2AD18"/>
+                </a:solidFill>
+                <a:latin typeface="Aptos Display" pitchFamily="34" charset="0"/>
+                <a:ea typeface="Aptos Display" pitchFamily="34" charset="-122"/>
+                <a:cs typeface="Aptos Display" pitchFamily="34" charset="-120"/>
               </a:rPr>
               <a:t>Dit zijn geen randvoorwaarden. Dit zijn de bottlenecks.</a:t>
             </a:r>
-            <a:endParaRPr lang="en-US" sz="1500" dirty="0"/>
+            <a:endParaRPr lang="en-US" sz="2200" dirty="0"/>
           </a:p>
         </p:txBody>
       </p:sp>
@@ -11090,6 +11280,74 @@
                 <a:cs typeface="Aptos" pitchFamily="34" charset="-120"/>
               </a:rPr>
               <a:t>Zonder kostdiscipline blijft sociale schaal vooral theater.</a:t>
+            </a:r>
+            <a:endParaRPr lang="en-US" sz="1200" dirty="0"/>
+          </a:p>
+        </p:txBody>
+      </p:sp>
+      <p:sp>
+        <p:nvSpPr>
+          <p:cNvPr id="26" name="Shape 23"/>
+          <p:cNvSpPr/>
+          <p:nvPr/>
+        </p:nvSpPr>
+        <p:spPr>
+          <a:xfrm>
+            <a:off x="713232" y="5541264"/>
+            <a:ext cx="10927080" cy="640080"/>
+          </a:xfrm>
+          <a:prstGeom prst="roundRect">
+            <a:avLst>
+              <a:gd name="adj" fmla="val 11429"/>
+            </a:avLst>
+          </a:prstGeom>
+          <a:solidFill>
+            <a:srgbClr val="1C2540"/>
+          </a:solidFill>
+          <a:ln w="12700">
+            <a:solidFill>
+              <a:srgbClr val="394258"/>
+            </a:solidFill>
+            <a:prstDash val="solid"/>
+          </a:ln>
+        </p:spPr>
+      </p:sp>
+      <p:sp>
+        <p:nvSpPr>
+          <p:cNvPr id="27" name="Text 24"/>
+          <p:cNvSpPr/>
+          <p:nvPr/>
+        </p:nvSpPr>
+        <p:spPr>
+          <a:xfrm>
+            <a:off x="932688" y="5705856"/>
+            <a:ext cx="10469880" cy="201168"/>
+          </a:xfrm>
+          <a:prstGeom prst="rect">
+            <a:avLst/>
+          </a:prstGeom>
+          <a:noFill/>
+          <a:ln/>
+        </p:spPr>
+        <p:txBody>
+          <a:bodyPr wrap="square" lIns="0" tIns="0" rIns="0" bIns="0" rtlCol="0" anchor="ctr">
+            <a:normAutofit/>
+          </a:bodyPr>
+          <a:lstStyle/>
+          <a:p>
+            <a:pPr indent="0" marL="0">
+              <a:buNone/>
+            </a:pPr>
+            <a:r>
+              <a:rPr lang="en-US" sz="1200" b="1" dirty="0">
+                <a:solidFill>
+                  <a:srgbClr val="FFFFFF"/>
+                </a:solidFill>
+                <a:latin typeface="Aptos" pitchFamily="34" charset="0"/>
+                <a:ea typeface="Aptos" pitchFamily="34" charset="-122"/>
+                <a:cs typeface="Aptos" pitchFamily="34" charset="-120"/>
+              </a:rPr>
+              <a:t>Takeaway: zonder identiteit, geheugen, governance en economics blijft 'agentsamenleving' vooral taal.</a:t>
             </a:r>
             <a:endParaRPr lang="en-US" sz="1200" dirty="0"/>
           </a:p>

</xml_diff>